<commit_message>
vault backup: 2026-09-25 14:55:58
</commit_message>
<xml_diff>
--- a/SDLC/Projects/TMP-failure-in-removing-chinese-character-in-lis-patient-pmi-sync-svc/assets/failure-in-removing-chinese-character-in-lis-patient-pmi-sync-svc.pptx
+++ b/SDLC/Projects/TMP-failure-in-removing-chinese-character-in-lis-patient-pmi-sync-svc/assets/failure-in-removing-chinese-character-in-lis-patient-pmi-sync-svc.pptx
@@ -1418,7 +1418,7 @@
         <p:spPr>
           <a:xfrm>
             <a:off x="758952" y="1835849"/>
-            <a:ext cx="8574786" cy="228600"/>
+            <a:ext cx="3657600" cy="228600"/>
           </a:xfrm>
           <a:prstGeom prst="rect">
             <a:avLst/>
@@ -1442,7 +1442,7 @@
                 <a:ea typeface="Segoe UI Semibold" pitchFamily="34" charset="-122"/>
                 <a:cs typeface="Segoe UI Semibold" pitchFamily="34" charset="-120"/>
               </a:rPr>
-              <a:t>TMP-FAILURE-IN-REMOVING-CHINESE-CHARACTER-IN-LIS-PATIENT-PMI-SYNC-SVC</a:t>
+              <a:t>LIS-XXXXX</a:t>
             </a:r>
             <a:endParaRPr lang="en-US" sz="1050" dirty="0"/>
           </a:p>
@@ -1450,133 +1450,49 @@
       </p:sp>
       <p:sp>
         <p:nvSpPr>
-          <p:cNvPr id="3" name="Shape 1"/>
-          <p:cNvSpPr/>
-          <p:nvPr/>
-        </p:nvSpPr>
-        <p:spPr>
-          <a:xfrm>
-            <a:off x="8071866" y="1950149"/>
-            <a:ext cx="301752" cy="10973"/>
-          </a:xfrm>
-          <a:prstGeom prst="rect">
-            <a:avLst/>
-          </a:prstGeom>
-          <a:solidFill>
-            <a:srgbClr val="38BDF8"/>
-          </a:solidFill>
-          <a:ln w="12700">
-            <a:solidFill>
-              <a:srgbClr val="38BDF8"/>
-            </a:solidFill>
-            <a:prstDash val="solid"/>
-          </a:ln>
-        </p:spPr>
-      </p:sp>
-      <p:sp>
-        <p:nvSpPr>
-          <p:cNvPr id="4" name="Text 2"/>
-          <p:cNvSpPr/>
-          <p:nvPr/>
-        </p:nvSpPr>
-        <p:spPr>
-          <a:xfrm>
-            <a:off x="8492490" y="1835849"/>
-            <a:ext cx="3089910" cy="228600"/>
-          </a:xfrm>
-          <a:prstGeom prst="rect">
-            <a:avLst/>
-          </a:prstGeom>
-          <a:noFill/>
-          <a:ln/>
-        </p:spPr>
-        <p:txBody>
-          <a:bodyPr wrap="square" lIns="0" tIns="0" rIns="0" bIns="0" rtlCol="0" anchor="ctr"/>
-          <a:lstStyle/>
-          <a:p>
-            <a:pPr indent="0" marL="0">
-              <a:buNone/>
-            </a:pPr>
-            <a:r>
-              <a:rPr lang="en-US" sz="1050" dirty="0">
-                <a:solidFill>
-                  <a:srgbClr val="94A3B8"/>
+          <p:cNvPr id="3" name="Text 1"/>
+          <p:cNvSpPr/>
+          <p:nvPr/>
+        </p:nvSpPr>
+        <p:spPr>
+          <a:xfrm>
+            <a:off x="758952" y="2201609"/>
+            <a:ext cx="9098280" cy="1109472"/>
+          </a:xfrm>
+          <a:prstGeom prst="rect">
+            <a:avLst/>
+          </a:prstGeom>
+          <a:noFill/>
+          <a:ln/>
+        </p:spPr>
+        <p:txBody>
+          <a:bodyPr wrap="square" lIns="0" tIns="0" rIns="0" bIns="0" rtlCol="0" anchor="t"/>
+          <a:lstStyle/>
+          <a:p>
+            <a:pPr algn="l" indent="0" marL="0">
+              <a:lnSpc>
+                <a:spcPct val="105000"/>
+              </a:lnSpc>
+              <a:buNone/>
+            </a:pPr>
+            <a:r>
+              <a:rPr lang="en-US" sz="3900" dirty="0">
+                <a:solidFill>
+                  <a:srgbClr val="FFFFFF"/>
                 </a:solidFill>
                 <a:latin typeface="Segoe UI Semibold" pitchFamily="34" charset="0"/>
                 <a:ea typeface="Segoe UI Semibold" pitchFamily="34" charset="-122"/>
                 <a:cs typeface="Segoe UI Semibold" pitchFamily="34" charset="-120"/>
               </a:rPr>
-              <a:t>LIS-10723  ·  CP3</a:t>
-            </a:r>
-            <a:endParaRPr lang="en-US" sz="1050" dirty="0"/>
-          </a:p>
-        </p:txBody>
-      </p:sp>
-      <p:sp>
-        <p:nvSpPr>
-          <p:cNvPr id="5" name="Text 3"/>
-          <p:cNvSpPr/>
-          <p:nvPr/>
-        </p:nvSpPr>
-        <p:spPr>
-          <a:xfrm>
-            <a:off x="758952" y="2201609"/>
-            <a:ext cx="9098280" cy="1109472"/>
-          </a:xfrm>
-          <a:prstGeom prst="rect">
-            <a:avLst/>
-          </a:prstGeom>
-          <a:noFill/>
-          <a:ln/>
-        </p:spPr>
-        <p:txBody>
-          <a:bodyPr wrap="square" lIns="0" tIns="0" rIns="0" bIns="0" rtlCol="0" anchor="t"/>
-          <a:lstStyle/>
-          <a:p>
-            <a:pPr algn="l" indent="0" marL="0">
-              <a:lnSpc>
-                <a:spcPct val="105000"/>
-              </a:lnSpc>
-              <a:buNone/>
-            </a:pPr>
-            <a:r>
-              <a:rPr lang="en-US" sz="3900" dirty="0">
-                <a:solidFill>
-                  <a:srgbClr val="FFFFFF"/>
-                </a:solidFill>
-                <a:latin typeface="Segoe UI Semibold" pitchFamily="34" charset="0"/>
-                <a:ea typeface="Segoe UI Semibold" pitchFamily="34" charset="-122"/>
-                <a:cs typeface="Segoe UI Semibold" pitchFamily="34" charset="-120"/>
-              </a:rPr>
-              <a:t>Chinese characters reach Sybase</a:t>
+              <a:t>Failure in removing chinese character in lis-patient-pmi-sync-svc</a:t>
             </a:r>
             <a:endParaRPr lang="en-US" sz="3900" dirty="0"/>
           </a:p>
-          <a:p>
-            <a:pPr algn="l" indent="0" marL="0">
-              <a:lnSpc>
-                <a:spcPct val="105000"/>
-              </a:lnSpc>
-              <a:buNone/>
-            </a:pPr>
-            <a:r>
-              <a:rPr lang="en-US" sz="3900" dirty="0">
-                <a:solidFill>
-                  <a:srgbClr val="FFFFFF"/>
-                </a:solidFill>
-                <a:latin typeface="Segoe UI Semibold" pitchFamily="34" charset="0"/>
-                <a:ea typeface="Segoe UI Semibold" pitchFamily="34" charset="-122"/>
-                <a:cs typeface="Segoe UI Semibold" pitchFamily="34" charset="-120"/>
-              </a:rPr>
-              <a:t>when the Oracle flag is not read</a:t>
-            </a:r>
-            <a:endParaRPr lang="en-US" sz="3900" dirty="0"/>
-          </a:p>
-        </p:txBody>
-      </p:sp>
-      <p:sp>
-        <p:nvSpPr>
-          <p:cNvPr id="6" name="Text 4"/>
+        </p:txBody>
+      </p:sp>
+      <p:sp>
+        <p:nvSpPr>
+          <p:cNvPr id="4" name="Text 2"/>
           <p:cNvSpPr/>
           <p:nvPr/>
         </p:nvSpPr>
@@ -1618,7 +1534,7 @@
       </p:sp>
       <p:sp>
         <p:nvSpPr>
-          <p:cNvPr id="7" name="Text 5"/>
+          <p:cNvPr id="5" name="Text 3"/>
           <p:cNvSpPr/>
           <p:nvPr/>
         </p:nvSpPr>
@@ -1660,7 +1576,7 @@
       </p:sp>
       <p:sp>
         <p:nvSpPr>
-          <p:cNvPr id="8" name="Text 6"/>
+          <p:cNvPr id="6" name="Text 4"/>
           <p:cNvSpPr/>
           <p:nvPr/>
         </p:nvSpPr>
@@ -1702,7 +1618,7 @@
       </p:sp>
       <p:sp>
         <p:nvSpPr>
-          <p:cNvPr id="9" name="Shape 7"/>
+          <p:cNvPr id="7" name="Shape 5"/>
           <p:cNvSpPr/>
           <p:nvPr/>
         </p:nvSpPr>
@@ -1727,7 +1643,7 @@
       </p:sp>
       <p:sp>
         <p:nvSpPr>
-          <p:cNvPr id="10" name="Text 8"/>
+          <p:cNvPr id="8" name="Text 6"/>
           <p:cNvSpPr/>
           <p:nvPr/>
         </p:nvSpPr>
@@ -1769,7 +1685,7 @@
       </p:sp>
       <p:sp>
         <p:nvSpPr>
-          <p:cNvPr id="11" name="Text 9"/>
+          <p:cNvPr id="9" name="Text 7"/>
           <p:cNvSpPr/>
           <p:nvPr/>
         </p:nvSpPr>
@@ -1811,7 +1727,7 @@
       </p:sp>
       <p:sp>
         <p:nvSpPr>
-          <p:cNvPr id="12" name="Shape 10"/>
+          <p:cNvPr id="10" name="Shape 8"/>
           <p:cNvSpPr/>
           <p:nvPr/>
         </p:nvSpPr>
@@ -1836,7 +1752,7 @@
       </p:sp>
       <p:sp>
         <p:nvSpPr>
-          <p:cNvPr id="13" name="Text 11"/>
+          <p:cNvPr id="11" name="Text 9"/>
           <p:cNvSpPr/>
           <p:nvPr/>
         </p:nvSpPr>
@@ -1878,7 +1794,7 @@
       </p:sp>
       <p:sp>
         <p:nvSpPr>
-          <p:cNvPr id="14" name="Text 12"/>
+          <p:cNvPr id="12" name="Text 10"/>
           <p:cNvSpPr/>
           <p:nvPr/>
         </p:nvSpPr>
@@ -1920,7 +1836,7 @@
       </p:sp>
       <p:sp>
         <p:nvSpPr>
-          <p:cNvPr id="15" name="Shape 13"/>
+          <p:cNvPr id="13" name="Shape 11"/>
           <p:cNvSpPr/>
           <p:nvPr/>
         </p:nvSpPr>
@@ -1945,7 +1861,7 @@
       </p:sp>
       <p:sp>
         <p:nvSpPr>
-          <p:cNvPr id="16" name="Text 14"/>
+          <p:cNvPr id="14" name="Text 12"/>
           <p:cNvSpPr/>
           <p:nvPr/>
         </p:nvSpPr>
@@ -1987,7 +1903,7 @@
       </p:sp>
       <p:sp>
         <p:nvSpPr>
-          <p:cNvPr id="17" name="Text 15"/>
+          <p:cNvPr id="15" name="Text 13"/>
           <p:cNvSpPr/>
           <p:nvPr/>
         </p:nvSpPr>
@@ -2021,7 +1937,7 @@
                 <a:ea typeface="Segoe UI" pitchFamily="34" charset="-122"/>
                 <a:cs typeface="Segoe UI" pitchFamily="34" charset="-120"/>
               </a:rPr>
-              <a:t>LIS Team</a:t>
+              <a:t>Tony Chong</a:t>
             </a:r>
             <a:endParaRPr lang="en-US" sz="1200" dirty="0"/>
           </a:p>
@@ -2029,39 +1945,14 @@
       </p:sp>
       <p:sp>
         <p:nvSpPr>
-          <p:cNvPr id="18" name="Shape 16"/>
-          <p:cNvSpPr/>
-          <p:nvPr/>
-        </p:nvSpPr>
-        <p:spPr>
-          <a:xfrm>
-            <a:off x="7295388" y="4592384"/>
-            <a:ext cx="10973" cy="384048"/>
-          </a:xfrm>
-          <a:prstGeom prst="rect">
-            <a:avLst/>
-          </a:prstGeom>
-          <a:solidFill>
-            <a:srgbClr val="1E293B"/>
-          </a:solidFill>
-          <a:ln w="12700">
-            <a:solidFill>
-              <a:srgbClr val="1E293B"/>
-            </a:solidFill>
-            <a:prstDash val="solid"/>
-          </a:ln>
-        </p:spPr>
-      </p:sp>
-      <p:sp>
-        <p:nvSpPr>
-          <p:cNvPr id="19" name="Text 17"/>
-          <p:cNvSpPr/>
-          <p:nvPr/>
-        </p:nvSpPr>
-        <p:spPr>
-          <a:xfrm>
-            <a:off x="7551420" y="4592384"/>
-            <a:ext cx="871728" cy="173736"/>
+          <p:cNvPr id="16" name="Text 14"/>
+          <p:cNvSpPr/>
+          <p:nvPr/>
+        </p:nvSpPr>
+        <p:spPr>
+          <a:xfrm>
+            <a:off x="758952" y="6053328"/>
+            <a:ext cx="10515600" cy="219456"/>
           </a:xfrm>
           <a:prstGeom prst="rect">
             <a:avLst/>
@@ -2088,91 +1979,7 @@
                 <a:ea typeface="Segoe UI" pitchFamily="34" charset="-122"/>
                 <a:cs typeface="Segoe UI" pitchFamily="34" charset="-120"/>
               </a:rPr>
-              <a:t>REVIEWERS</a:t>
-            </a:r>
-            <a:endParaRPr lang="en-US" sz="1050" dirty="0"/>
-          </a:p>
-        </p:txBody>
-      </p:sp>
-      <p:sp>
-        <p:nvSpPr>
-          <p:cNvPr id="20" name="Text 18"/>
-          <p:cNvSpPr/>
-          <p:nvPr/>
-        </p:nvSpPr>
-        <p:spPr>
-          <a:xfrm>
-            <a:off x="7551420" y="4802696"/>
-            <a:ext cx="871728" cy="219456"/>
-          </a:xfrm>
-          <a:prstGeom prst="rect">
-            <a:avLst/>
-          </a:prstGeom>
-          <a:noFill/>
-          <a:ln/>
-        </p:spPr>
-        <p:txBody>
-          <a:bodyPr wrap="square" lIns="0" tIns="0" rIns="0" bIns="0" rtlCol="0" anchor="t"/>
-          <a:lstStyle/>
-          <a:p>
-            <a:pPr algn="l" indent="0" marL="0">
-              <a:lnSpc>
-                <a:spcPct val="115000"/>
-              </a:lnSpc>
-              <a:buNone/>
-            </a:pPr>
-            <a:r>
-              <a:rPr lang="en-US" sz="1200" dirty="0">
-                <a:solidFill>
-                  <a:srgbClr val="F1F5F9"/>
-                </a:solidFill>
-                <a:latin typeface="Segoe UI" pitchFamily="34" charset="0"/>
-                <a:ea typeface="Segoe UI" pitchFamily="34" charset="-122"/>
-                <a:cs typeface="Segoe UI" pitchFamily="34" charset="-120"/>
-              </a:rPr>
-              <a:t>Tony Chong</a:t>
-            </a:r>
-            <a:endParaRPr lang="en-US" sz="1200" dirty="0"/>
-          </a:p>
-        </p:txBody>
-      </p:sp>
-      <p:sp>
-        <p:nvSpPr>
-          <p:cNvPr id="21" name="Text 19"/>
-          <p:cNvSpPr/>
-          <p:nvPr/>
-        </p:nvSpPr>
-        <p:spPr>
-          <a:xfrm>
-            <a:off x="758952" y="6053328"/>
-            <a:ext cx="10515600" cy="219456"/>
-          </a:xfrm>
-          <a:prstGeom prst="rect">
-            <a:avLst/>
-          </a:prstGeom>
-          <a:noFill/>
-          <a:ln/>
-        </p:spPr>
-        <p:txBody>
-          <a:bodyPr wrap="square" lIns="0" tIns="0" rIns="0" bIns="0" rtlCol="0" anchor="t"/>
-          <a:lstStyle/>
-          <a:p>
-            <a:pPr algn="l" indent="0" marL="0">
-              <a:lnSpc>
-                <a:spcPct val="115000"/>
-              </a:lnSpc>
-              <a:buNone/>
-            </a:pPr>
-            <a:r>
-              <a:rPr lang="en-US" sz="1050" dirty="0">
-                <a:solidFill>
-                  <a:srgbClr val="64748B"/>
-                </a:solidFill>
-                <a:latin typeface="Segoe UI" pitchFamily="34" charset="0"/>
-                <a:ea typeface="Segoe UI" pitchFamily="34" charset="-122"/>
-                <a:cs typeface="Segoe UI" pitchFamily="34" charset="-120"/>
-              </a:rPr>
-              <a:t>Related upgrade LIS-10723  ·  for CP3</a:t>
+              <a:t>Related upgrade LIS-10723</a:t>
             </a:r>
             <a:endParaRPr lang="en-US" sz="1050" dirty="0"/>
           </a:p>

</xml_diff>

<commit_message>
vault backup: 2026-09-25 15:21:25
</commit_message>
<xml_diff>
--- a/SDLC/Projects/TMP-failure-in-removing-chinese-character-in-lis-patient-pmi-sync-svc/assets/failure-in-removing-chinese-character-in-lis-patient-pmi-sync-svc.pptx
+++ b/SDLC/Projects/TMP-failure-in-removing-chinese-character-in-lis-patient-pmi-sync-svc/assets/failure-in-removing-chinese-character-in-lis-patient-pmi-sync-svc.pptx
@@ -11,10 +11,9 @@
     <p:sldId id="259" r:id="rId5"/>
     <p:sldId id="260" r:id="rId6"/>
     <p:sldId id="261" r:id="rId7"/>
-    <p:sldId id="262" r:id="rId8"/>
   </p:sldIdLst>
   <p:notesMasterIdLst>
-    <p:notesMasterId r:id="rId9"/>
+    <p:notesMasterId r:id="rId8"/>
   </p:notesMasterIdLst>
   <p:sldSz cx="12192000" cy="6858000"/>
   <p:notesSz cx="6858000" cy="12192000"/>
@@ -596,7 +595,7 @@
           <a:p>
             <a:r>
               <a:rPr lang="en-US" dirty="0"/>
-              <a:t>Five stops. Promotion and fallback sit on one slide: ship the library, or put the previous one back.</a:t>
+              <a:t>Four stops. Promotion and fallback sit on one slide: ship the library, or put the previous one back.</a:t>
             </a:r>
             <a:endParaRPr lang="en-US" dirty="0"/>
           </a:p>
@@ -772,7 +771,7 @@
           <a:p>
             <a:r>
               <a:rPr lang="en-US" dirty="0"/>
-              <a:t>We do not move the hospital transaction onto Oracle. That would commit hospital work already done. Only the flag read uses the Oracle connection.</a:t>
+              <a:t>The replace logic is already in lis-patient-pmi-sync-svc. The library fix is what lets that check succeed.</a:t>
             </a:r>
             <a:endParaRPr lang="en-US" dirty="0"/>
           </a:p>
@@ -860,7 +859,7 @@
           <a:p>
             <a:r>
               <a:rPr lang="en-US" dirty="0"/>
-              <a:t>The replace logic is already in lis-patient-pmi-sync-svc. The library fix is what lets that check succeed.</a:t>
+              <a:t>DEVQA, SIT, and PROD keep the same JDBC settings. What changes is the library binary. You know the rollback worked when the old warning is back. A wrong saved answer is cleared with DELETE /api/clearCachedDBConn/{hospital}/{lab}.</a:t>
             </a:r>
             <a:endParaRPr lang="en-US" dirty="0"/>
           </a:p>
@@ -948,7 +947,7 @@
           <a:p>
             <a:r>
               <a:rPr lang="en-US" dirty="0"/>
-              <a:t>DEVQA, SIT, and PROD keep the same JDBC settings. What changes is the library binary. You know the rollback worked when the old warning is back. A wrong saved answer is cleared with DELETE /api/clearCachedDBConn/{hospital}/{lab}.</a:t>
+              <a:t>Likely question: does patient sync source change? No. The logic to remove Chinese characters is already there. It runs again once the Oracle flag can be read.</a:t>
             </a:r>
             <a:endParaRPr lang="en-US" dirty="0"/>
           </a:p>
@@ -972,94 +971,6 @@
             <a:fld id="{F7021451-1387-4CA6-816F-3879F97B5CBC}" type="slidenum">
               <a:rPr lang="en-US"/>
               <a:t>6</a:t>
-            </a:fld>
-            <a:endParaRPr lang="en-US"/>
-          </a:p>
-        </p:txBody>
-      </p:sp>
-    </p:spTree>
-    <p:extLst>
-      <p:ext uri="{BB962C8B-B14F-4D97-AF65-F5344CB8AC3E}">
-        <p14:creationId xmlns:p14="http://schemas.microsoft.com/office/powerpoint/2010/main" val="1024086991"/>
-      </p:ext>
-    </p:extLst>
-  </p:cSld>
-  <p:clrMapOvr>
-    <a:masterClrMapping/>
-  </p:clrMapOvr>
-</p:notes>
-</file>
-
-<file path=ppt/notesSlides/notesSlide7.xml><?xml version="1.0" encoding="utf-8"?>
-<p:notes xmlns:a="http://schemas.openxmlformats.org/drawingml/2006/main" xmlns:r="http://schemas.openxmlformats.org/officeDocument/2006/relationships" xmlns:p="http://schemas.openxmlformats.org/presentationml/2006/main">
-  <p:cSld>
-    <p:spTree>
-      <p:nvGrpSpPr>
-        <p:cNvPr id="1" name=""/>
-        <p:cNvGrpSpPr/>
-        <p:nvPr/>
-      </p:nvGrpSpPr>
-      <p:grpSpPr>
-        <a:xfrm>
-          <a:off x="0" y="0"/>
-          <a:ext cx="0" cy="0"/>
-          <a:chOff x="0" y="0"/>
-          <a:chExt cx="0" cy="0"/>
-        </a:xfrm>
-      </p:grpSpPr>
-      <p:sp>
-        <p:nvSpPr>
-          <p:cNvPr id="2" name="Slide Image Placeholder 1"/>
-          <p:cNvSpPr>
-            <a:spLocks noGrp="1" noRot="1" noChangeAspect="1"/>
-          </p:cNvSpPr>
-          <p:nvPr>
-            <p:ph type="sldImg"/>
-          </p:nvPr>
-        </p:nvSpPr>
-        <p:spPr/>
-      </p:sp>
-      <p:sp>
-        <p:nvSpPr>
-          <p:cNvPr id="3" name="Notes Placeholder 2"/>
-          <p:cNvSpPr>
-            <a:spLocks noGrp="1"/>
-          </p:cNvSpPr>
-          <p:nvPr>
-            <p:ph type="body" idx="1"/>
-          </p:nvPr>
-        </p:nvSpPr>
-        <p:spPr/>
-        <p:txBody>
-          <a:bodyPr/>
-          <a:lstStyle/>
-          <a:p>
-            <a:r>
-              <a:rPr lang="en-US" dirty="0"/>
-              <a:t>Likely question: does patient sync source change? No. The logic to remove Chinese characters is already there. It runs again once the Oracle flag can be read.</a:t>
-            </a:r>
-            <a:endParaRPr lang="en-US" dirty="0"/>
-          </a:p>
-        </p:txBody>
-      </p:sp>
-      <p:sp>
-        <p:nvSpPr>
-          <p:cNvPr id="4" name="Slide Number Placeholder 3"/>
-          <p:cNvSpPr>
-            <a:spLocks noGrp="1"/>
-          </p:cNvSpPr>
-          <p:nvPr>
-            <p:ph type="sldNum" sz="quarter" idx="10"/>
-          </p:nvPr>
-        </p:nvSpPr>
-        <p:spPr/>
-        <p:txBody>
-          <a:bodyPr/>
-          <a:lstStyle/>
-          <a:p>
-            <a:fld id="{F7021451-1387-4CA6-816F-3879F97B5CBC}" type="slidenum">
-              <a:rPr lang="en-US"/>
-              <a:t>7</a:t>
             </a:fld>
             <a:endParaRPr lang="en-US"/>
           </a:p>
@@ -2089,7 +2000,7 @@
                 <a:ea typeface="Segoe UI Semibold" pitchFamily="34" charset="-122"/>
                 <a:cs typeface="Segoe UI Semibold" pitchFamily="34" charset="-120"/>
               </a:rPr>
-              <a:t>Five stops</a:t>
+              <a:t>Four stops</a:t>
             </a:r>
             <a:endParaRPr lang="en-US" sz="2400" dirty="0"/>
           </a:p>
@@ -2103,7 +2014,7 @@
         </p:nvSpPr>
         <p:spPr>
           <a:xfrm>
-            <a:off x="609600" y="1581912"/>
+            <a:off x="609600" y="2057400"/>
             <a:ext cx="10972800" cy="804672"/>
           </a:xfrm>
           <a:prstGeom prst="roundRect">
@@ -2130,7 +2041,7 @@
         </p:nvSpPr>
         <p:spPr>
           <a:xfrm>
-            <a:off x="847344" y="1581912"/>
+            <a:off x="847344" y="2057400"/>
             <a:ext cx="502920" cy="804672"/>
           </a:xfrm>
           <a:prstGeom prst="rect">
@@ -2172,7 +2083,7 @@
         </p:nvSpPr>
         <p:spPr>
           <a:xfrm>
-            <a:off x="1341120" y="1728216"/>
+            <a:off x="1341120" y="2203704"/>
             <a:ext cx="10003536" cy="246888"/>
           </a:xfrm>
           <a:prstGeom prst="rect">
@@ -2214,7 +2125,7 @@
         </p:nvSpPr>
         <p:spPr>
           <a:xfrm>
-            <a:off x="1341120" y="1993392"/>
+            <a:off x="1341120" y="2468880"/>
             <a:ext cx="10003536" cy="219456"/>
           </a:xfrm>
           <a:prstGeom prst="rect">
@@ -2256,7 +2167,7 @@
         </p:nvSpPr>
         <p:spPr>
           <a:xfrm>
-            <a:off x="609600" y="2532888"/>
+            <a:off x="609600" y="3008376"/>
             <a:ext cx="10972800" cy="804672"/>
           </a:xfrm>
           <a:prstGeom prst="roundRect">
@@ -2283,7 +2194,7 @@
         </p:nvSpPr>
         <p:spPr>
           <a:xfrm>
-            <a:off x="847344" y="2532888"/>
+            <a:off x="847344" y="3008376"/>
             <a:ext cx="502920" cy="804672"/>
           </a:xfrm>
           <a:prstGeom prst="rect">
@@ -2325,7 +2236,7 @@
         </p:nvSpPr>
         <p:spPr>
           <a:xfrm>
-            <a:off x="1341120" y="2679192"/>
+            <a:off x="1341120" y="3154680"/>
             <a:ext cx="10003536" cy="246888"/>
           </a:xfrm>
           <a:prstGeom prst="rect">
@@ -2353,7 +2264,7 @@
                 <a:ea typeface="Segoe UI" pitchFamily="34" charset="-122"/>
                 <a:cs typeface="Segoe UI" pitchFamily="34" charset="-120"/>
               </a:rPr>
-              <a:t>Existing Design</a:t>
+              <a:t>Proposed Change</a:t>
             </a:r>
             <a:endParaRPr lang="en-US" sz="1350" dirty="0"/>
           </a:p>
@@ -2367,7 +2278,7 @@
         </p:nvSpPr>
         <p:spPr>
           <a:xfrm>
-            <a:off x="1341120" y="2944368"/>
+            <a:off x="1341120" y="3419856"/>
             <a:ext cx="10003536" cy="219456"/>
           </a:xfrm>
           <a:prstGeom prst="rect">
@@ -2395,7 +2306,7 @@
                 <a:ea typeface="Segoe UI" pitchFamily="34" charset="-122"/>
                 <a:cs typeface="Segoe UI" pitchFamily="34" charset="-120"/>
               </a:rPr>
-              <a:t>the flag check does not reach Oracle</a:t>
+              <a:t>read the flag, then remove when Sybase</a:t>
             </a:r>
             <a:endParaRPr lang="en-US" sz="1125" dirty="0"/>
           </a:p>
@@ -2409,7 +2320,7 @@
         </p:nvSpPr>
         <p:spPr>
           <a:xfrm>
-            <a:off x="609600" y="3483864"/>
+            <a:off x="609600" y="3959352"/>
             <a:ext cx="10972800" cy="804672"/>
           </a:xfrm>
           <a:prstGeom prst="roundRect">
@@ -2436,7 +2347,7 @@
         </p:nvSpPr>
         <p:spPr>
           <a:xfrm>
-            <a:off x="847344" y="3483864"/>
+            <a:off x="847344" y="3959352"/>
             <a:ext cx="502920" cy="804672"/>
           </a:xfrm>
           <a:prstGeom prst="rect">
@@ -2478,7 +2389,7 @@
         </p:nvSpPr>
         <p:spPr>
           <a:xfrm>
-            <a:off x="1341120" y="3630168"/>
+            <a:off x="1341120" y="4105656"/>
             <a:ext cx="10003536" cy="246888"/>
           </a:xfrm>
           <a:prstGeom prst="rect">
@@ -2506,7 +2417,7 @@
                 <a:ea typeface="Segoe UI" pitchFamily="34" charset="-122"/>
                 <a:cs typeface="Segoe UI" pitchFamily="34" charset="-120"/>
               </a:rPr>
-              <a:t>Proposed Change</a:t>
+              <a:t>Promotion and fallback</a:t>
             </a:r>
             <a:endParaRPr lang="en-US" sz="1350" dirty="0"/>
           </a:p>
@@ -2520,7 +2431,7 @@
         </p:nvSpPr>
         <p:spPr>
           <a:xfrm>
-            <a:off x="1341120" y="3895344"/>
+            <a:off x="1341120" y="4370832"/>
             <a:ext cx="10003536" cy="219456"/>
           </a:xfrm>
           <a:prstGeom prst="rect">
@@ -2548,7 +2459,7 @@
                 <a:ea typeface="Segoe UI" pitchFamily="34" charset="-122"/>
                 <a:cs typeface="Segoe UI" pitchFamily="34" charset="-120"/>
               </a:rPr>
-              <a:t>read the flag, then remove when Sybase</a:t>
+              <a:t>new library, or the previous one</a:t>
             </a:r>
             <a:endParaRPr lang="en-US" sz="1125" dirty="0"/>
           </a:p>
@@ -2562,7 +2473,7 @@
         </p:nvSpPr>
         <p:spPr>
           <a:xfrm>
-            <a:off x="609600" y="4434840"/>
+            <a:off x="609600" y="4910328"/>
             <a:ext cx="10972800" cy="804672"/>
           </a:xfrm>
           <a:prstGeom prst="roundRect">
@@ -2589,7 +2500,7 @@
         </p:nvSpPr>
         <p:spPr>
           <a:xfrm>
-            <a:off x="847344" y="4434840"/>
+            <a:off x="847344" y="4910328"/>
             <a:ext cx="502920" cy="804672"/>
           </a:xfrm>
           <a:prstGeom prst="rect">
@@ -2631,7 +2542,7 @@
         </p:nvSpPr>
         <p:spPr>
           <a:xfrm>
-            <a:off x="1341120" y="4581144"/>
+            <a:off x="1341120" y="5056632"/>
             <a:ext cx="10003536" cy="246888"/>
           </a:xfrm>
           <a:prstGeom prst="rect">
@@ -2659,7 +2570,7 @@
                 <a:ea typeface="Segoe UI" pitchFamily="34" charset="-122"/>
                 <a:cs typeface="Segoe UI" pitchFamily="34" charset="-120"/>
               </a:rPr>
-              <a:t>Promotion and fallback</a:t>
+              <a:t>Open Questions</a:t>
             </a:r>
             <a:endParaRPr lang="en-US" sz="1350" dirty="0"/>
           </a:p>
@@ -2673,160 +2584,7 @@
         </p:nvSpPr>
         <p:spPr>
           <a:xfrm>
-            <a:off x="1341120" y="4846320"/>
-            <a:ext cx="10003536" cy="219456"/>
-          </a:xfrm>
-          <a:prstGeom prst="rect">
-            <a:avLst/>
-          </a:prstGeom>
-          <a:noFill/>
-          <a:ln/>
-        </p:spPr>
-        <p:txBody>
-          <a:bodyPr wrap="square" lIns="0" tIns="0" rIns="0" bIns="0" rtlCol="0" anchor="ctr"/>
-          <a:lstStyle/>
-          <a:p>
-            <a:pPr algn="l" indent="0" marL="0">
-              <a:lnSpc>
-                <a:spcPct val="115000"/>
-              </a:lnSpc>
-              <a:buNone/>
-            </a:pPr>
-            <a:r>
-              <a:rPr lang="en-US" sz="1125" dirty="0">
-                <a:solidFill>
-                  <a:srgbClr val="64748B"/>
-                </a:solidFill>
-                <a:latin typeface="Segoe UI" pitchFamily="34" charset="0"/>
-                <a:ea typeface="Segoe UI" pitchFamily="34" charset="-122"/>
-                <a:cs typeface="Segoe UI" pitchFamily="34" charset="-120"/>
-              </a:rPr>
-              <a:t>new library, or the previous one</a:t>
-            </a:r>
-            <a:endParaRPr lang="en-US" sz="1125" dirty="0"/>
-          </a:p>
-        </p:txBody>
-      </p:sp>
-      <p:sp>
-        <p:nvSpPr>
-          <p:cNvPr id="20" name="Shape 18"/>
-          <p:cNvSpPr/>
-          <p:nvPr/>
-        </p:nvSpPr>
-        <p:spPr>
-          <a:xfrm>
-            <a:off x="609600" y="5385816"/>
-            <a:ext cx="10972800" cy="804672"/>
-          </a:xfrm>
-          <a:prstGeom prst="roundRect">
-            <a:avLst>
-              <a:gd name="adj" fmla="val 13636"/>
-            </a:avLst>
-          </a:prstGeom>
-          <a:solidFill>
-            <a:srgbClr val="FFFFFF"/>
-          </a:solidFill>
-          <a:ln w="9525">
-            <a:solidFill>
-              <a:srgbClr val="E2E8F0"/>
-            </a:solidFill>
-            <a:prstDash val="solid"/>
-          </a:ln>
-        </p:spPr>
-      </p:sp>
-      <p:sp>
-        <p:nvSpPr>
-          <p:cNvPr id="21" name="Text 19"/>
-          <p:cNvSpPr/>
-          <p:nvPr/>
-        </p:nvSpPr>
-        <p:spPr>
-          <a:xfrm>
-            <a:off x="847344" y="5385816"/>
-            <a:ext cx="502920" cy="804672"/>
-          </a:xfrm>
-          <a:prstGeom prst="rect">
-            <a:avLst/>
-          </a:prstGeom>
-          <a:noFill/>
-          <a:ln/>
-        </p:spPr>
-        <p:txBody>
-          <a:bodyPr wrap="square" lIns="0" tIns="0" rIns="0" bIns="0" rtlCol="0" anchor="ctr"/>
-          <a:lstStyle/>
-          <a:p>
-            <a:pPr algn="l" indent="0" marL="0">
-              <a:lnSpc>
-                <a:spcPct val="115000"/>
-              </a:lnSpc>
-              <a:buNone/>
-            </a:pPr>
-            <a:r>
-              <a:rPr lang="en-US" sz="1500" dirty="0">
-                <a:solidFill>
-                  <a:srgbClr val="0284C7"/>
-                </a:solidFill>
-                <a:latin typeface="Segoe UI Semibold" pitchFamily="34" charset="0"/>
-                <a:ea typeface="Segoe UI Semibold" pitchFamily="34" charset="-122"/>
-                <a:cs typeface="Segoe UI Semibold" pitchFamily="34" charset="-120"/>
-              </a:rPr>
-              <a:t>05</a:t>
-            </a:r>
-            <a:endParaRPr lang="en-US" sz="1500" dirty="0"/>
-          </a:p>
-        </p:txBody>
-      </p:sp>
-      <p:sp>
-        <p:nvSpPr>
-          <p:cNvPr id="22" name="Text 20"/>
-          <p:cNvSpPr/>
-          <p:nvPr/>
-        </p:nvSpPr>
-        <p:spPr>
-          <a:xfrm>
-            <a:off x="1341120" y="5532120"/>
-            <a:ext cx="10003536" cy="246888"/>
-          </a:xfrm>
-          <a:prstGeom prst="rect">
-            <a:avLst/>
-          </a:prstGeom>
-          <a:noFill/>
-          <a:ln/>
-        </p:spPr>
-        <p:txBody>
-          <a:bodyPr wrap="square" lIns="0" tIns="0" rIns="0" bIns="0" rtlCol="0" anchor="ctr"/>
-          <a:lstStyle/>
-          <a:p>
-            <a:pPr algn="l" indent="0" marL="0">
-              <a:lnSpc>
-                <a:spcPct val="115000"/>
-              </a:lnSpc>
-              <a:buNone/>
-            </a:pPr>
-            <a:r>
-              <a:rPr lang="en-US" sz="1350" b="1" dirty="0">
-                <a:solidFill>
-                  <a:srgbClr val="0F172A"/>
-                </a:solidFill>
-                <a:latin typeface="Segoe UI" pitchFamily="34" charset="0"/>
-                <a:ea typeface="Segoe UI" pitchFamily="34" charset="-122"/>
-                <a:cs typeface="Segoe UI" pitchFamily="34" charset="-120"/>
-              </a:rPr>
-              <a:t>Open Questions</a:t>
-            </a:r>
-            <a:endParaRPr lang="en-US" sz="1350" dirty="0"/>
-          </a:p>
-        </p:txBody>
-      </p:sp>
-      <p:sp>
-        <p:nvSpPr>
-          <p:cNvPr id="23" name="Text 21"/>
-          <p:cNvSpPr/>
-          <p:nvPr/>
-        </p:nvSpPr>
-        <p:spPr>
-          <a:xfrm>
-            <a:off x="1341120" y="5797296"/>
+            <a:off x="1341120" y="5321808"/>
             <a:ext cx="10003536" cy="219456"/>
           </a:xfrm>
           <a:prstGeom prst="rect">
@@ -3515,7 +3273,7 @@
                 <a:ea typeface="Consolas" pitchFamily="34" charset="-122"/>
                 <a:cs typeface="Consolas" pitchFamily="34" charset="-120"/>
               </a:rPr>
-              <a:t>Sybase</a:t>
+              <a:t>LIS-10723</a:t>
             </a:r>
             <a:endParaRPr lang="en-US" sz="1125" dirty="0"/>
           </a:p>
@@ -3729,7 +3487,7 @@
                 <a:ea typeface="Segoe UI Semibold" pitchFamily="34" charset="-122"/>
                 <a:cs typeface="Segoe UI Semibold" pitchFamily="34" charset="-120"/>
               </a:rPr>
-              <a:t>EXISTING DESIGN</a:t>
+              <a:t>PROPOSED CHANGE</a:t>
             </a:r>
             <a:endParaRPr lang="en-US" sz="1050" dirty="0"/>
           </a:p>
@@ -3768,7 +3526,7 @@
                 <a:ea typeface="Segoe UI Semibold" pitchFamily="34" charset="-122"/>
                 <a:cs typeface="Segoe UI Semibold" pitchFamily="34" charset="-120"/>
               </a:rPr>
-              <a:t>The flag check does not reach Oracle</a:t>
+              <a:t>Fix the read of the Oracle flag, then remove when the connection is Sybase</a:t>
             </a:r>
             <a:endParaRPr lang="en-US" sz="2400" dirty="0"/>
           </a:p>
@@ -3782,12 +3540,12 @@
         </p:nvSpPr>
         <p:spPr>
           <a:xfrm>
-            <a:off x="609600" y="2882646"/>
-            <a:ext cx="5335524" cy="2007108"/>
+            <a:off x="609600" y="2860834"/>
+            <a:ext cx="3505200" cy="2050732"/>
           </a:xfrm>
           <a:prstGeom prst="roundRect">
             <a:avLst>
-              <a:gd name="adj" fmla="val 5467"/>
+              <a:gd name="adj" fmla="val 5351"/>
             </a:avLst>
           </a:prstGeom>
           <a:solidFill>
@@ -3801,77 +3559,189 @@
           </a:ln>
         </p:spPr>
       </p:sp>
-      <p:sp>
-        <p:nvSpPr>
-          <p:cNvPr id="5" name="Text 3"/>
-          <p:cNvSpPr/>
-          <p:nvPr/>
-        </p:nvSpPr>
-        <p:spPr>
-          <a:xfrm>
-            <a:off x="883920" y="3207258"/>
-            <a:ext cx="609219" cy="228600"/>
-          </a:xfrm>
-          <a:prstGeom prst="roundRect">
-            <a:avLst>
-              <a:gd name="adj" fmla="val 20000"/>
-            </a:avLst>
-          </a:prstGeom>
-          <a:solidFill>
-            <a:srgbClr val="FEE2E2"/>
-          </a:solidFill>
-          <a:ln>
-            <a:solidFill>
-              <a:srgbClr val="FEE2E2"/>
-            </a:solidFill>
-          </a:ln>
-        </p:spPr>
-        <p:txBody>
-          <a:bodyPr wrap="square" lIns="0" tIns="0" rIns="0" bIns="0" rtlCol="0" anchor="ctr"/>
-          <a:lstStyle/>
-          <a:p>
-            <a:pPr algn="ctr" indent="0" marL="0">
-              <a:buNone/>
-            </a:pPr>
-            <a:r>
-              <a:rPr lang="en-US" sz="975" b="1" dirty="0">
-                <a:solidFill>
-                  <a:srgbClr val="B91C1C"/>
+      <p:pic>
+        <p:nvPicPr>
+          <p:cNvPr id="5" name="Image 0" descr="D:\Github\HA-Notes\LIS\skills\design-review-pptx\assets\icons\png\accent\database.png">    </p:cNvPr>
+          <p:cNvPicPr>
+            <a:picLocks noChangeAspect="1"/>
+          </p:cNvPicPr>
+          <p:nvPr/>
+        </p:nvPicPr>
+        <p:blipFill>
+          <a:blip r:embed="rId1"/>
+          <a:stretch>
+            <a:fillRect/>
+          </a:stretch>
+        </p:blipFill>
+        <p:spPr>
+          <a:xfrm>
+            <a:off x="883920" y="3180874"/>
+            <a:ext cx="265176" cy="265176"/>
+          </a:xfrm>
+          <a:prstGeom prst="rect">
+            <a:avLst/>
+          </a:prstGeom>
+        </p:spPr>
+      </p:pic>
+      <p:sp>
+        <p:nvSpPr>
+          <p:cNvPr id="6" name="Text 3"/>
+          <p:cNvSpPr/>
+          <p:nvPr/>
+        </p:nvSpPr>
+        <p:spPr>
+          <a:xfrm>
+            <a:off x="883920" y="3638074"/>
+            <a:ext cx="2956560" cy="219075"/>
+          </a:xfrm>
+          <a:prstGeom prst="rect">
+            <a:avLst/>
+          </a:prstGeom>
+          <a:noFill/>
+          <a:ln/>
+        </p:spPr>
+        <p:txBody>
+          <a:bodyPr wrap="square" lIns="0" tIns="0" rIns="0" bIns="0" rtlCol="0" anchor="t"/>
+          <a:lstStyle/>
+          <a:p>
+            <a:pPr algn="l" indent="0" marL="0">
+              <a:lnSpc>
+                <a:spcPct val="110000"/>
+              </a:lnSpc>
+              <a:buNone/>
+            </a:pPr>
+            <a:r>
+              <a:rPr lang="en-US" sz="1500" dirty="0">
+                <a:solidFill>
+                  <a:srgbClr val="0F172A"/>
+                </a:solidFill>
+                <a:latin typeface="Segoe UI Semibold" pitchFamily="34" charset="0"/>
+                <a:ea typeface="Segoe UI Semibold" pitchFamily="34" charset="-122"/>
+                <a:cs typeface="Segoe UI Semibold" pitchFamily="34" charset="-120"/>
+              </a:rPr>
+              <a:t>Read the flag on Oracle</a:t>
+            </a:r>
+            <a:endParaRPr lang="en-US" sz="1500" dirty="0"/>
+          </a:p>
+        </p:txBody>
+      </p:sp>
+      <p:sp>
+        <p:nvSpPr>
+          <p:cNvPr id="7" name="Text 4"/>
+          <p:cNvSpPr/>
+          <p:nvPr/>
+        </p:nvSpPr>
+        <p:spPr>
+          <a:xfrm>
+            <a:off x="883920" y="3948589"/>
+            <a:ext cx="2956560" cy="798385"/>
+          </a:xfrm>
+          <a:prstGeom prst="rect">
+            <a:avLst/>
+          </a:prstGeom>
+          <a:noFill/>
+          <a:ln/>
+        </p:spPr>
+        <p:txBody>
+          <a:bodyPr wrap="square" lIns="0" tIns="0" rIns="0" bIns="0" rtlCol="0" anchor="t"/>
+          <a:lstStyle/>
+          <a:p>
+            <a:pPr algn="l" indent="0" marL="0">
+              <a:lnSpc>
+                <a:spcPct val="120000"/>
+              </a:lnSpc>
+              <a:buNone/>
+            </a:pPr>
+            <a:r>
+              <a:rPr lang="en-US" sz="1350" dirty="0">
+                <a:solidFill>
+                  <a:srgbClr val="475569"/>
                 </a:solidFill>
                 <a:latin typeface="Segoe UI" pitchFamily="34" charset="0"/>
                 <a:ea typeface="Segoe UI" pitchFamily="34" charset="-122"/>
                 <a:cs typeface="Segoe UI" pitchFamily="34" charset="-120"/>
               </a:rPr>
-              <a:t>TODAY</a:t>
-            </a:r>
-            <a:endParaRPr lang="en-US" sz="975" dirty="0"/>
-          </a:p>
-        </p:txBody>
-      </p:sp>
-      <p:sp>
-        <p:nvSpPr>
-          <p:cNvPr id="6" name="Text 4"/>
-          <p:cNvSpPr/>
-          <p:nvPr/>
-        </p:nvSpPr>
-        <p:spPr>
-          <a:xfrm>
-            <a:off x="1602867" y="3175254"/>
-            <a:ext cx="4067937" cy="292608"/>
-          </a:xfrm>
-          <a:prstGeom prst="rect">
-            <a:avLst/>
-          </a:prstGeom>
-          <a:noFill/>
-          <a:ln/>
-        </p:spPr>
-        <p:txBody>
-          <a:bodyPr wrap="square" lIns="0" tIns="0" rIns="0" bIns="0" rtlCol="0" anchor="ctr"/>
+              <a:t>Connect to Oracle and read the flag while the hospital database is still in use.</a:t>
+            </a:r>
+            <a:endParaRPr lang="en-US" sz="1350" dirty="0"/>
+          </a:p>
+        </p:txBody>
+      </p:sp>
+      <p:sp>
+        <p:nvSpPr>
+          <p:cNvPr id="8" name="Shape 5"/>
+          <p:cNvSpPr/>
+          <p:nvPr/>
+        </p:nvSpPr>
+        <p:spPr>
+          <a:xfrm>
+            <a:off x="4343400" y="2860834"/>
+            <a:ext cx="3505200" cy="2050732"/>
+          </a:xfrm>
+          <a:prstGeom prst="roundRect">
+            <a:avLst>
+              <a:gd name="adj" fmla="val 5351"/>
+            </a:avLst>
+          </a:prstGeom>
+          <a:solidFill>
+            <a:srgbClr val="FFFFFF"/>
+          </a:solidFill>
+          <a:ln w="9525">
+            <a:solidFill>
+              <a:srgbClr val="E2E8F0"/>
+            </a:solidFill>
+            <a:prstDash val="solid"/>
+          </a:ln>
+        </p:spPr>
+      </p:sp>
+      <p:pic>
+        <p:nvPicPr>
+          <p:cNvPr id="9" name="Image 1" descr="D:\Github\HA-Notes\LIS\skills\design-review-pptx\assets\icons\png\accent\filter.png">    </p:cNvPr>
+          <p:cNvPicPr>
+            <a:picLocks noChangeAspect="1"/>
+          </p:cNvPicPr>
+          <p:nvPr/>
+        </p:nvPicPr>
+        <p:blipFill>
+          <a:blip r:embed="rId2"/>
+          <a:stretch>
+            <a:fillRect/>
+          </a:stretch>
+        </p:blipFill>
+        <p:spPr>
+          <a:xfrm>
+            <a:off x="4617720" y="3180874"/>
+            <a:ext cx="265176" cy="265176"/>
+          </a:xfrm>
+          <a:prstGeom prst="rect">
+            <a:avLst/>
+          </a:prstGeom>
+        </p:spPr>
+      </p:pic>
+      <p:sp>
+        <p:nvSpPr>
+          <p:cNvPr id="10" name="Text 6"/>
+          <p:cNvSpPr/>
+          <p:nvPr/>
+        </p:nvSpPr>
+        <p:spPr>
+          <a:xfrm>
+            <a:off x="4617720" y="3638074"/>
+            <a:ext cx="2956560" cy="219075"/>
+          </a:xfrm>
+          <a:prstGeom prst="rect">
+            <a:avLst/>
+          </a:prstGeom>
+          <a:noFill/>
+          <a:ln/>
+        </p:spPr>
+        <p:txBody>
+          <a:bodyPr wrap="square" lIns="0" tIns="0" rIns="0" bIns="0" rtlCol="0" anchor="t"/>
           <a:lstStyle/>
           <a:p>
             <a:pPr algn="l" indent="0" marL="0">
               <a:lnSpc>
-                <a:spcPct val="115000"/>
+                <a:spcPct val="110000"/>
               </a:lnSpc>
               <a:buNone/>
             </a:pPr>
@@ -3884,7 +3754,7 @@
                 <a:ea typeface="Segoe UI Semibold" pitchFamily="34" charset="-122"/>
                 <a:cs typeface="Segoe UI Semibold" pitchFamily="34" charset="-120"/>
               </a:rPr>
-              <a:t>Characters are not removed</a:t>
+              <a:t>Sybase means replace</a:t>
             </a:r>
             <a:endParaRPr lang="en-US" sz="1500" dirty="0"/>
           </a:p>
@@ -3892,14 +3762,14 @@
       </p:sp>
       <p:sp>
         <p:nvSpPr>
-          <p:cNvPr id="7" name="Text 5"/>
-          <p:cNvSpPr/>
-          <p:nvPr/>
-        </p:nvSpPr>
-        <p:spPr>
-          <a:xfrm>
-            <a:off x="883920" y="3632454"/>
-            <a:ext cx="4786884" cy="208788"/>
+          <p:cNvPr id="11" name="Text 7"/>
+          <p:cNvSpPr/>
+          <p:nvPr/>
+        </p:nvSpPr>
+        <p:spPr>
+          <a:xfrm>
+            <a:off x="4617720" y="3948589"/>
+            <a:ext cx="2956560" cy="798385"/>
           </a:xfrm>
           <a:prstGeom prst="rect">
             <a:avLst/>
@@ -3913,433 +3783,157 @@
           <a:p>
             <a:pPr algn="l" indent="0" marL="0">
               <a:lnSpc>
-                <a:spcPct val="115000"/>
+                <a:spcPct val="120000"/>
               </a:lnSpc>
               <a:buNone/>
             </a:pPr>
             <a:r>
-              <a:rPr lang="en-US" sz="1200" b="1" dirty="0">
-                <a:solidFill>
-                  <a:srgbClr val="334155"/>
+              <a:rPr lang="en-US" sz="1350" dirty="0">
+                <a:solidFill>
+                  <a:srgbClr val="475569"/>
                 </a:solidFill>
                 <a:latin typeface="Segoe UI" pitchFamily="34" charset="0"/>
                 <a:ea typeface="Segoe UI" pitchFamily="34" charset="-122"/>
                 <a:cs typeface="Segoe UI" pitchFamily="34" charset="-120"/>
               </a:rPr>
-              <a:t>Check: </a:t>
-            </a:r>
+              <a:t>If the flag says the hospital is Sybase, replace the Chinese characters.</a:t>
+            </a:r>
+            <a:endParaRPr lang="en-US" sz="1350" dirty="0"/>
+          </a:p>
+        </p:txBody>
+      </p:sp>
+      <p:sp>
+        <p:nvSpPr>
+          <p:cNvPr id="12" name="Shape 8"/>
+          <p:cNvSpPr/>
+          <p:nvPr/>
+        </p:nvSpPr>
+        <p:spPr>
+          <a:xfrm>
+            <a:off x="8077200" y="2860834"/>
+            <a:ext cx="3505200" cy="2050732"/>
+          </a:xfrm>
+          <a:prstGeom prst="roundRect">
+            <a:avLst>
+              <a:gd name="adj" fmla="val 5351"/>
+            </a:avLst>
+          </a:prstGeom>
+          <a:solidFill>
+            <a:srgbClr val="FFFFFF"/>
+          </a:solidFill>
+          <a:ln w="9525">
+            <a:solidFill>
+              <a:srgbClr val="E2E8F0"/>
+            </a:solidFill>
+            <a:prstDash val="solid"/>
+          </a:ln>
+        </p:spPr>
+      </p:sp>
+      <p:pic>
+        <p:nvPicPr>
+          <p:cNvPr id="13" name="Image 2" descr="D:\Github\HA-Notes\LIS\skills\design-review-pptx\assets\icons\png\accent\hospital.png">    </p:cNvPr>
+          <p:cNvPicPr>
+            <a:picLocks noChangeAspect="1"/>
+          </p:cNvPicPr>
+          <p:nvPr/>
+        </p:nvPicPr>
+        <p:blipFill>
+          <a:blip r:embed="rId3"/>
+          <a:stretch>
+            <a:fillRect/>
+          </a:stretch>
+        </p:blipFill>
+        <p:spPr>
+          <a:xfrm>
+            <a:off x="8351520" y="3180874"/>
+            <a:ext cx="265176" cy="265176"/>
+          </a:xfrm>
+          <a:prstGeom prst="rect">
+            <a:avLst/>
+          </a:prstGeom>
+        </p:spPr>
+      </p:pic>
+      <p:sp>
+        <p:nvSpPr>
+          <p:cNvPr id="14" name="Text 9"/>
+          <p:cNvSpPr/>
+          <p:nvPr/>
+        </p:nvSpPr>
+        <p:spPr>
+          <a:xfrm>
+            <a:off x="8351520" y="3638074"/>
+            <a:ext cx="2956560" cy="219075"/>
+          </a:xfrm>
+          <a:prstGeom prst="rect">
+            <a:avLst/>
+          </a:prstGeom>
+          <a:noFill/>
+          <a:ln/>
+        </p:spPr>
+        <p:txBody>
+          <a:bodyPr wrap="square" lIns="0" tIns="0" rIns="0" bIns="0" rtlCol="0" anchor="t"/>
+          <a:lstStyle/>
+          <a:p>
             <a:pPr algn="l" indent="0" marL="0">
               <a:lnSpc>
-                <a:spcPct val="115000"/>
+                <a:spcPct val="110000"/>
               </a:lnSpc>
               <a:buNone/>
             </a:pPr>
             <a:r>
-              <a:rPr lang="en-US" sz="1200" dirty="0">
-                <a:solidFill>
-                  <a:srgbClr val="334155"/>
+              <a:rPr lang="en-US" sz="1500" dirty="0">
+                <a:solidFill>
+                  <a:srgbClr val="0F172A"/>
+                </a:solidFill>
+                <a:latin typeface="Segoe UI Semibold" pitchFamily="34" charset="0"/>
+                <a:ea typeface="Segoe UI Semibold" pitchFamily="34" charset="-122"/>
+                <a:cs typeface="Segoe UI Semibold" pitchFamily="34" charset="-120"/>
+              </a:rPr>
+              <a:t>Hospital work stays open</a:t>
+            </a:r>
+            <a:endParaRPr lang="en-US" sz="1500" dirty="0"/>
+          </a:p>
+        </p:txBody>
+      </p:sp>
+      <p:sp>
+        <p:nvSpPr>
+          <p:cNvPr id="15" name="Text 10"/>
+          <p:cNvSpPr/>
+          <p:nvPr/>
+        </p:nvSpPr>
+        <p:spPr>
+          <a:xfrm>
+            <a:off x="8351520" y="3948589"/>
+            <a:ext cx="2956560" cy="798385"/>
+          </a:xfrm>
+          <a:prstGeom prst="rect">
+            <a:avLst/>
+          </a:prstGeom>
+          <a:noFill/>
+          <a:ln/>
+        </p:spPr>
+        <p:txBody>
+          <a:bodyPr wrap="square" lIns="0" tIns="0" rIns="0" bIns="0" rtlCol="0" anchor="t"/>
+          <a:lstStyle/>
+          <a:p>
+            <a:pPr algn="l" indent="0" marL="0">
+              <a:lnSpc>
+                <a:spcPct val="120000"/>
+              </a:lnSpc>
+              <a:buNone/>
+            </a:pPr>
+            <a:r>
+              <a:rPr lang="en-US" sz="1350" dirty="0">
+                <a:solidFill>
+                  <a:srgbClr val="475569"/>
                 </a:solidFill>
                 <a:latin typeface="Segoe UI" pitchFamily="34" charset="0"/>
                 <a:ea typeface="Segoe UI" pitchFamily="34" charset="-122"/>
                 <a:cs typeface="Segoe UI" pitchFamily="34" charset="-120"/>
               </a:rPr>
-              <a:t>Oracle flag is not read</a:t>
-            </a:r>
-            <a:endParaRPr lang="en-US" sz="1200" dirty="0"/>
-          </a:p>
-        </p:txBody>
-      </p:sp>
-      <p:sp>
-        <p:nvSpPr>
-          <p:cNvPr id="8" name="Text 6"/>
-          <p:cNvSpPr/>
-          <p:nvPr/>
-        </p:nvSpPr>
-        <p:spPr>
-          <a:xfrm>
-            <a:off x="883920" y="3960114"/>
-            <a:ext cx="4786884" cy="208788"/>
-          </a:xfrm>
-          <a:prstGeom prst="rect">
-            <a:avLst/>
-          </a:prstGeom>
-          <a:noFill/>
-          <a:ln/>
-        </p:spPr>
-        <p:txBody>
-          <a:bodyPr wrap="square" lIns="0" tIns="0" rIns="0" bIns="0" rtlCol="0" anchor="t"/>
-          <a:lstStyle/>
-          <a:p>
-            <a:pPr algn="l" indent="0" marL="0">
-              <a:lnSpc>
-                <a:spcPct val="115000"/>
-              </a:lnSpc>
-              <a:buNone/>
-            </a:pPr>
-            <a:r>
-              <a:rPr lang="en-US" sz="1200" b="1" dirty="0">
-                <a:solidFill>
-                  <a:srgbClr val="334155"/>
-                </a:solidFill>
-                <a:latin typeface="Segoe UI" pitchFamily="34" charset="0"/>
-                <a:ea typeface="Segoe UI" pitchFamily="34" charset="-122"/>
-                <a:cs typeface="Segoe UI" pitchFamily="34" charset="-120"/>
-              </a:rPr>
-              <a:t>Result: </a:t>
-            </a:r>
-            <a:pPr algn="l" indent="0" marL="0">
-              <a:lnSpc>
-                <a:spcPct val="115000"/>
-              </a:lnSpc>
-              <a:buNone/>
-            </a:pPr>
-            <a:r>
-              <a:rPr lang="en-US" sz="1200" dirty="0">
-                <a:solidFill>
-                  <a:srgbClr val="334155"/>
-                </a:solidFill>
-                <a:latin typeface="Segoe UI" pitchFamily="34" charset="0"/>
-                <a:ea typeface="Segoe UI" pitchFamily="34" charset="-122"/>
-                <a:cs typeface="Segoe UI" pitchFamily="34" charset="-120"/>
-              </a:rPr>
-              <a:t>replace logic does not run</a:t>
-            </a:r>
-            <a:endParaRPr lang="en-US" sz="1200" dirty="0"/>
-          </a:p>
-        </p:txBody>
-      </p:sp>
-      <p:sp>
-        <p:nvSpPr>
-          <p:cNvPr id="9" name="Text 7"/>
-          <p:cNvSpPr/>
-          <p:nvPr/>
-        </p:nvSpPr>
-        <p:spPr>
-          <a:xfrm>
-            <a:off x="883920" y="4287774"/>
-            <a:ext cx="4786884" cy="208788"/>
-          </a:xfrm>
-          <a:prstGeom prst="rect">
-            <a:avLst/>
-          </a:prstGeom>
-          <a:noFill/>
-          <a:ln/>
-        </p:spPr>
-        <p:txBody>
-          <a:bodyPr wrap="square" lIns="0" tIns="0" rIns="0" bIns="0" rtlCol="0" anchor="t"/>
-          <a:lstStyle/>
-          <a:p>
-            <a:pPr algn="l" indent="0" marL="0">
-              <a:lnSpc>
-                <a:spcPct val="115000"/>
-              </a:lnSpc>
-              <a:buNone/>
-            </a:pPr>
-            <a:r>
-              <a:rPr lang="en-US" sz="1200" b="1" dirty="0">
-                <a:solidFill>
-                  <a:srgbClr val="334155"/>
-                </a:solidFill>
-                <a:latin typeface="Segoe UI" pitchFamily="34" charset="0"/>
-                <a:ea typeface="Segoe UI" pitchFamily="34" charset="-122"/>
-                <a:cs typeface="Segoe UI" pitchFamily="34" charset="-120"/>
-              </a:rPr>
-              <a:t>Store: </a:t>
-            </a:r>
-            <a:pPr algn="l" indent="0" marL="0">
-              <a:lnSpc>
-                <a:spcPct val="115000"/>
-              </a:lnSpc>
-              <a:buNone/>
-            </a:pPr>
-            <a:r>
-              <a:rPr lang="en-US" sz="1200" dirty="0">
-                <a:solidFill>
-                  <a:srgbClr val="334155"/>
-                </a:solidFill>
-                <a:latin typeface="Segoe UI" pitchFamily="34" charset="0"/>
-                <a:ea typeface="Segoe UI" pitchFamily="34" charset="-122"/>
-                <a:cs typeface="Segoe UI" pitchFamily="34" charset="-120"/>
-              </a:rPr>
-              <a:t>Chinese characters go into Sybase</a:t>
-            </a:r>
-            <a:endParaRPr lang="en-US" sz="1200" dirty="0"/>
-          </a:p>
-        </p:txBody>
-      </p:sp>
-      <p:sp>
-        <p:nvSpPr>
-          <p:cNvPr id="10" name="Shape 8"/>
-          <p:cNvSpPr/>
-          <p:nvPr/>
-        </p:nvSpPr>
-        <p:spPr>
-          <a:xfrm>
-            <a:off x="6246876" y="2882646"/>
-            <a:ext cx="5335524" cy="2007108"/>
-          </a:xfrm>
-          <a:prstGeom prst="roundRect">
-            <a:avLst>
-              <a:gd name="adj" fmla="val 5467"/>
-            </a:avLst>
-          </a:prstGeom>
-          <a:solidFill>
-            <a:srgbClr val="FFFFFF"/>
-          </a:solidFill>
-          <a:ln w="19050">
-            <a:solidFill>
-              <a:srgbClr val="0284C7"/>
-            </a:solidFill>
-            <a:prstDash val="solid"/>
-          </a:ln>
-        </p:spPr>
-      </p:sp>
-      <p:sp>
-        <p:nvSpPr>
-          <p:cNvPr id="11" name="Text 9"/>
-          <p:cNvSpPr/>
-          <p:nvPr/>
-        </p:nvSpPr>
-        <p:spPr>
-          <a:xfrm>
-            <a:off x="6521196" y="3207258"/>
-            <a:ext cx="832104" cy="228600"/>
-          </a:xfrm>
-          <a:prstGeom prst="roundRect">
-            <a:avLst>
-              <a:gd name="adj" fmla="val 20000"/>
-            </a:avLst>
-          </a:prstGeom>
-          <a:solidFill>
-            <a:srgbClr val="E0F2FE"/>
-          </a:solidFill>
-          <a:ln>
-            <a:solidFill>
-              <a:srgbClr val="E0F2FE"/>
-            </a:solidFill>
-          </a:ln>
-        </p:spPr>
-        <p:txBody>
-          <a:bodyPr wrap="square" lIns="0" tIns="0" rIns="0" bIns="0" rtlCol="0" anchor="ctr"/>
-          <a:lstStyle/>
-          <a:p>
-            <a:pPr algn="ctr" indent="0" marL="0">
-              <a:buNone/>
-            </a:pPr>
-            <a:r>
-              <a:rPr lang="en-US" sz="975" b="1" dirty="0">
-                <a:solidFill>
-                  <a:srgbClr val="0369A1"/>
-                </a:solidFill>
-                <a:latin typeface="Segoe UI" pitchFamily="34" charset="0"/>
-                <a:ea typeface="Segoe UI" pitchFamily="34" charset="-122"/>
-                <a:cs typeface="Segoe UI" pitchFamily="34" charset="-120"/>
-              </a:rPr>
-              <a:t>PROPOSED</a:t>
-            </a:r>
-            <a:endParaRPr lang="en-US" sz="975" dirty="0"/>
-          </a:p>
-        </p:txBody>
-      </p:sp>
-      <p:sp>
-        <p:nvSpPr>
-          <p:cNvPr id="12" name="Text 10"/>
-          <p:cNvSpPr/>
-          <p:nvPr/>
-        </p:nvSpPr>
-        <p:spPr>
-          <a:xfrm>
-            <a:off x="7463028" y="3175254"/>
-            <a:ext cx="3845052" cy="292608"/>
-          </a:xfrm>
-          <a:prstGeom prst="rect">
-            <a:avLst/>
-          </a:prstGeom>
-          <a:noFill/>
-          <a:ln/>
-        </p:spPr>
-        <p:txBody>
-          <a:bodyPr wrap="square" lIns="0" tIns="0" rIns="0" bIns="0" rtlCol="0" anchor="ctr"/>
-          <a:lstStyle/>
-          <a:p>
-            <a:pPr algn="l" indent="0" marL="0">
-              <a:lnSpc>
-                <a:spcPct val="115000"/>
-              </a:lnSpc>
-              <a:buNone/>
-            </a:pPr>
-            <a:r>
-              <a:rPr lang="en-US" sz="1500" dirty="0">
-                <a:solidFill>
-                  <a:srgbClr val="0F172A"/>
-                </a:solidFill>
-                <a:latin typeface="Segoe UI Semibold" pitchFamily="34" charset="0"/>
-                <a:ea typeface="Segoe UI Semibold" pitchFamily="34" charset="-122"/>
-                <a:cs typeface="Segoe UI Semibold" pitchFamily="34" charset="-120"/>
-              </a:rPr>
-              <a:t>Read the flag on Oracle</a:t>
-            </a:r>
-            <a:endParaRPr lang="en-US" sz="1500" dirty="0"/>
-          </a:p>
-        </p:txBody>
-      </p:sp>
-      <p:sp>
-        <p:nvSpPr>
-          <p:cNvPr id="13" name="Text 11"/>
-          <p:cNvSpPr/>
-          <p:nvPr/>
-        </p:nvSpPr>
-        <p:spPr>
-          <a:xfrm>
-            <a:off x="6521196" y="3632454"/>
-            <a:ext cx="4786884" cy="208788"/>
-          </a:xfrm>
-          <a:prstGeom prst="rect">
-            <a:avLst/>
-          </a:prstGeom>
-          <a:noFill/>
-          <a:ln/>
-        </p:spPr>
-        <p:txBody>
-          <a:bodyPr wrap="square" lIns="0" tIns="0" rIns="0" bIns="0" rtlCol="0" anchor="t"/>
-          <a:lstStyle/>
-          <a:p>
-            <a:pPr algn="l" indent="0" marL="0">
-              <a:lnSpc>
-                <a:spcPct val="115000"/>
-              </a:lnSpc>
-              <a:buNone/>
-            </a:pPr>
-            <a:r>
-              <a:rPr lang="en-US" sz="1200" b="1" dirty="0">
-                <a:solidFill>
-                  <a:srgbClr val="334155"/>
-                </a:solidFill>
-                <a:latin typeface="Segoe UI" pitchFamily="34" charset="0"/>
-                <a:ea typeface="Segoe UI" pitchFamily="34" charset="-122"/>
-                <a:cs typeface="Segoe UI" pitchFamily="34" charset="-120"/>
-              </a:rPr>
-              <a:t>Check: </a:t>
-            </a:r>
-            <a:pPr algn="l" indent="0" marL="0">
-              <a:lnSpc>
-                <a:spcPct val="115000"/>
-              </a:lnSpc>
-              <a:buNone/>
-            </a:pPr>
-            <a:r>
-              <a:rPr lang="en-US" sz="1200" dirty="0">
-                <a:solidFill>
-                  <a:srgbClr val="334155"/>
-                </a:solidFill>
-                <a:latin typeface="Segoe UI" pitchFamily="34" charset="0"/>
-                <a:ea typeface="Segoe UI" pitchFamily="34" charset="-122"/>
-                <a:cs typeface="Segoe UI" pitchFamily="34" charset="-120"/>
-              </a:rPr>
-              <a:t>connect to Oracle and read the flag</a:t>
-            </a:r>
-            <a:endParaRPr lang="en-US" sz="1200" dirty="0"/>
-          </a:p>
-        </p:txBody>
-      </p:sp>
-      <p:sp>
-        <p:nvSpPr>
-          <p:cNvPr id="14" name="Text 12"/>
-          <p:cNvSpPr/>
-          <p:nvPr/>
-        </p:nvSpPr>
-        <p:spPr>
-          <a:xfrm>
-            <a:off x="6521196" y="3960114"/>
-            <a:ext cx="4786884" cy="208788"/>
-          </a:xfrm>
-          <a:prstGeom prst="rect">
-            <a:avLst/>
-          </a:prstGeom>
-          <a:noFill/>
-          <a:ln/>
-        </p:spPr>
-        <p:txBody>
-          <a:bodyPr wrap="square" lIns="0" tIns="0" rIns="0" bIns="0" rtlCol="0" anchor="t"/>
-          <a:lstStyle/>
-          <a:p>
-            <a:pPr algn="l" indent="0" marL="0">
-              <a:lnSpc>
-                <a:spcPct val="115000"/>
-              </a:lnSpc>
-              <a:buNone/>
-            </a:pPr>
-            <a:r>
-              <a:rPr lang="en-US" sz="1200" b="1" dirty="0">
-                <a:solidFill>
-                  <a:srgbClr val="334155"/>
-                </a:solidFill>
-                <a:latin typeface="Segoe UI" pitchFamily="34" charset="0"/>
-                <a:ea typeface="Segoe UI" pitchFamily="34" charset="-122"/>
-                <a:cs typeface="Segoe UI" pitchFamily="34" charset="-120"/>
-              </a:rPr>
-              <a:t>Sybase: </a:t>
-            </a:r>
-            <a:pPr algn="l" indent="0" marL="0">
-              <a:lnSpc>
-                <a:spcPct val="115000"/>
-              </a:lnSpc>
-              <a:buNone/>
-            </a:pPr>
-            <a:r>
-              <a:rPr lang="en-US" sz="1200" dirty="0">
-                <a:solidFill>
-                  <a:srgbClr val="334155"/>
-                </a:solidFill>
-                <a:latin typeface="Segoe UI" pitchFamily="34" charset="0"/>
-                <a:ea typeface="Segoe UI" pitchFamily="34" charset="-122"/>
-                <a:cs typeface="Segoe UI" pitchFamily="34" charset="-120"/>
-              </a:rPr>
-              <a:t>replace the Chinese characters</a:t>
-            </a:r>
-            <a:endParaRPr lang="en-US" sz="1200" dirty="0"/>
-          </a:p>
-        </p:txBody>
-      </p:sp>
-      <p:sp>
-        <p:nvSpPr>
-          <p:cNvPr id="15" name="Text 13"/>
-          <p:cNvSpPr/>
-          <p:nvPr/>
-        </p:nvSpPr>
-        <p:spPr>
-          <a:xfrm>
-            <a:off x="6521196" y="4287774"/>
-            <a:ext cx="4786884" cy="208788"/>
-          </a:xfrm>
-          <a:prstGeom prst="rect">
-            <a:avLst/>
-          </a:prstGeom>
-          <a:noFill/>
-          <a:ln/>
-        </p:spPr>
-        <p:txBody>
-          <a:bodyPr wrap="square" lIns="0" tIns="0" rIns="0" bIns="0" rtlCol="0" anchor="t"/>
-          <a:lstStyle/>
-          <a:p>
-            <a:pPr algn="l" indent="0" marL="0">
-              <a:lnSpc>
-                <a:spcPct val="115000"/>
-              </a:lnSpc>
-              <a:buNone/>
-            </a:pPr>
-            <a:r>
-              <a:rPr lang="en-US" sz="1200" dirty="0">
-                <a:solidFill>
-                  <a:srgbClr val="334155"/>
-                </a:solidFill>
-                <a:latin typeface="Segoe UI" pitchFamily="34" charset="0"/>
-                <a:ea typeface="Segoe UI" pitchFamily="34" charset="-122"/>
-                <a:cs typeface="Segoe UI" pitchFamily="34" charset="-120"/>
-              </a:rPr>
-              <a:t>Hospital work stays open</a:t>
-            </a:r>
-            <a:endParaRPr lang="en-US" sz="1200" dirty="0"/>
+              <a:t>Do not switch the hospital transaction over to Oracle.</a:t>
+            </a:r>
+            <a:endParaRPr lang="en-US" sz="1350" dirty="0"/>
           </a:p>
         </p:txBody>
       </p:sp>
@@ -4408,7 +4002,7 @@
                 <a:ea typeface="Segoe UI Semibold" pitchFamily="34" charset="-122"/>
                 <a:cs typeface="Segoe UI Semibold" pitchFamily="34" charset="-120"/>
               </a:rPr>
-              <a:t>PROPOSED CHANGE</a:t>
+              <a:t>PROMOTION AND FALLBACK</a:t>
             </a:r>
             <a:endParaRPr lang="en-US" sz="1050" dirty="0"/>
           </a:p>
@@ -4447,7 +4041,7 @@
                 <a:ea typeface="Segoe UI Semibold" pitchFamily="34" charset="-122"/>
                 <a:cs typeface="Segoe UI Semibold" pitchFamily="34" charset="-120"/>
               </a:rPr>
-              <a:t>Read the Oracle flag, then remove when the hospital is Sybase</a:t>
+              <a:t>Ship the new library, or put the previous one back</a:t>
             </a:r>
             <a:endParaRPr lang="en-US" sz="2400" dirty="0"/>
           </a:p>
@@ -4461,12 +4055,12 @@
         </p:nvSpPr>
         <p:spPr>
           <a:xfrm>
-            <a:off x="609600" y="2860834"/>
-            <a:ext cx="3505200" cy="2050732"/>
+            <a:off x="609600" y="2873073"/>
+            <a:ext cx="5335524" cy="2026253"/>
           </a:xfrm>
           <a:prstGeom prst="roundRect">
             <a:avLst>
-              <a:gd name="adj" fmla="val 5351"/>
+              <a:gd name="adj" fmla="val 5415"/>
             </a:avLst>
           </a:prstGeom>
           <a:solidFill>
@@ -4482,7 +4076,7 @@
       </p:sp>
       <p:pic>
         <p:nvPicPr>
-          <p:cNvPr id="5" name="Image 0" descr="D:\Github\HA-Notes\LIS\skills\design-review-pptx\assets\icons\png\accent\database.png">    </p:cNvPr>
+          <p:cNvPr id="5" name="Image 0" descr="D:\Github\HA-Notes\LIS\skills\design-review-pptx\assets\icons\png\success\cloud-arrow-up.png">    </p:cNvPr>
           <p:cNvPicPr>
             <a:picLocks noChangeAspect="1"/>
           </p:cNvPicPr>
@@ -4496,7 +4090,7 @@
         </p:blipFill>
         <p:spPr>
           <a:xfrm>
-            <a:off x="883920" y="3180874"/>
+            <a:off x="883920" y="3179397"/>
             <a:ext cx="265176" cy="265176"/>
           </a:xfrm>
           <a:prstGeom prst="rect">
@@ -4512,22 +4106,22 @@
         </p:nvSpPr>
         <p:spPr>
           <a:xfrm>
-            <a:off x="883920" y="3638074"/>
-            <a:ext cx="2956560" cy="219075"/>
-          </a:xfrm>
-          <a:prstGeom prst="rect">
-            <a:avLst/>
-          </a:prstGeom>
-          <a:noFill/>
-          <a:ln/>
-        </p:spPr>
-        <p:txBody>
-          <a:bodyPr wrap="square" lIns="0" tIns="0" rIns="0" bIns="0" rtlCol="0" anchor="t"/>
+            <a:off x="1249680" y="3165681"/>
+            <a:ext cx="4421124" cy="292608"/>
+          </a:xfrm>
+          <a:prstGeom prst="rect">
+            <a:avLst/>
+          </a:prstGeom>
+          <a:noFill/>
+          <a:ln/>
+        </p:spPr>
+        <p:txBody>
+          <a:bodyPr wrap="square" lIns="0" tIns="0" rIns="0" bIns="0" rtlCol="0" anchor="ctr"/>
           <a:lstStyle/>
           <a:p>
             <a:pPr algn="l" indent="0" marL="0">
               <a:lnSpc>
-                <a:spcPct val="110000"/>
+                <a:spcPct val="115000"/>
               </a:lnSpc>
               <a:buNone/>
             </a:pPr>
@@ -4540,7 +4134,7 @@
                 <a:ea typeface="Segoe UI Semibold" pitchFamily="34" charset="-122"/>
                 <a:cs typeface="Segoe UI Semibold" pitchFamily="34" charset="-120"/>
               </a:rPr>
-              <a:t>Read the flag on Oracle</a:t>
+              <a:t>Promotion</a:t>
             </a:r>
             <a:endParaRPr lang="en-US" sz="1500" dirty="0"/>
           </a:p>
@@ -4554,54 +4148,273 @@
         </p:nvSpPr>
         <p:spPr>
           <a:xfrm>
-            <a:off x="883920" y="3948589"/>
-            <a:ext cx="2956560" cy="798385"/>
-          </a:xfrm>
-          <a:prstGeom prst="rect">
-            <a:avLst/>
-          </a:prstGeom>
-          <a:noFill/>
-          <a:ln/>
-        </p:spPr>
-        <p:txBody>
-          <a:bodyPr wrap="square" lIns="0" tIns="0" rIns="0" bIns="0" rtlCol="0" anchor="t"/>
-          <a:lstStyle/>
-          <a:p>
-            <a:pPr algn="l" indent="0" marL="0">
-              <a:lnSpc>
-                <a:spcPct val="120000"/>
-              </a:lnSpc>
-              <a:buNone/>
-            </a:pPr>
-            <a:r>
-              <a:rPr lang="en-US" sz="1350" dirty="0">
-                <a:solidFill>
-                  <a:srgbClr val="475569"/>
+            <a:off x="883920" y="3595449"/>
+            <a:ext cx="228600" cy="228600"/>
+          </a:xfrm>
+          <a:prstGeom prst="ellipse">
+            <a:avLst/>
+          </a:prstGeom>
+          <a:solidFill>
+            <a:srgbClr val="DCFCE7"/>
+          </a:solidFill>
+          <a:ln>
+            <a:solidFill>
+              <a:srgbClr val="DCFCE7"/>
+            </a:solidFill>
+          </a:ln>
+        </p:spPr>
+        <p:txBody>
+          <a:bodyPr wrap="square" lIns="0" tIns="0" rIns="0" bIns="0" rtlCol="0" anchor="ctr"/>
+          <a:lstStyle/>
+          <a:p>
+            <a:pPr algn="ctr" indent="0" marL="0">
+              <a:buNone/>
+            </a:pPr>
+            <a:r>
+              <a:rPr lang="en-US" sz="975" b="1" dirty="0">
+                <a:solidFill>
+                  <a:srgbClr val="15803D"/>
                 </a:solidFill>
                 <a:latin typeface="Segoe UI" pitchFamily="34" charset="0"/>
                 <a:ea typeface="Segoe UI" pitchFamily="34" charset="-122"/>
                 <a:cs typeface="Segoe UI" pitchFamily="34" charset="-120"/>
               </a:rPr>
-              <a:t>Connect to Oracle and read the flag while the hospital database is still in use.</a:t>
-            </a:r>
-            <a:endParaRPr lang="en-US" sz="1350" dirty="0"/>
-          </a:p>
-        </p:txBody>
-      </p:sp>
-      <p:sp>
-        <p:nvSpPr>
-          <p:cNvPr id="8" name="Shape 5"/>
-          <p:cNvSpPr/>
-          <p:nvPr/>
-        </p:nvSpPr>
-        <p:spPr>
-          <a:xfrm>
-            <a:off x="4343400" y="2860834"/>
-            <a:ext cx="3505200" cy="2050732"/>
+              <a:t>1</a:t>
+            </a:r>
+            <a:endParaRPr lang="en-US" sz="975" dirty="0"/>
+          </a:p>
+        </p:txBody>
+      </p:sp>
+      <p:sp>
+        <p:nvSpPr>
+          <p:cNvPr id="8" name="Text 5"/>
+          <p:cNvSpPr/>
+          <p:nvPr/>
+        </p:nvSpPr>
+        <p:spPr>
+          <a:xfrm>
+            <a:off x="1222248" y="3622881"/>
+            <a:ext cx="4448556" cy="196882"/>
+          </a:xfrm>
+          <a:prstGeom prst="rect">
+            <a:avLst/>
+          </a:prstGeom>
+          <a:noFill/>
+          <a:ln/>
+        </p:spPr>
+        <p:txBody>
+          <a:bodyPr wrap="square" lIns="0" tIns="0" rIns="0" bIns="0" rtlCol="0" anchor="t"/>
+          <a:lstStyle/>
+          <a:p>
+            <a:pPr algn="l" indent="0" marL="0">
+              <a:lnSpc>
+                <a:spcPct val="115000"/>
+              </a:lnSpc>
+              <a:buNone/>
+            </a:pPr>
+            <a:r>
+              <a:rPr lang="en-US" sz="1125" dirty="0">
+                <a:solidFill>
+                  <a:srgbClr val="334155"/>
+                </a:solidFill>
+                <a:latin typeface="Segoe UI" pitchFamily="34" charset="0"/>
+                <a:ea typeface="Segoe UI" pitchFamily="34" charset="-122"/>
+                <a:cs typeface="Segoe UI" pitchFamily="34" charset="-120"/>
+              </a:rPr>
+              <a:t>Ship a new data-source build</a:t>
+            </a:r>
+            <a:endParaRPr lang="en-US" sz="1125" dirty="0"/>
+          </a:p>
+        </p:txBody>
+      </p:sp>
+      <p:sp>
+        <p:nvSpPr>
+          <p:cNvPr id="9" name="Text 6"/>
+          <p:cNvSpPr/>
+          <p:nvPr/>
+        </p:nvSpPr>
+        <p:spPr>
+          <a:xfrm>
+            <a:off x="883920" y="3929491"/>
+            <a:ext cx="228600" cy="228600"/>
+          </a:xfrm>
+          <a:prstGeom prst="ellipse">
+            <a:avLst/>
+          </a:prstGeom>
+          <a:solidFill>
+            <a:srgbClr val="DCFCE7"/>
+          </a:solidFill>
+          <a:ln>
+            <a:solidFill>
+              <a:srgbClr val="DCFCE7"/>
+            </a:solidFill>
+          </a:ln>
+        </p:spPr>
+        <p:txBody>
+          <a:bodyPr wrap="square" lIns="0" tIns="0" rIns="0" bIns="0" rtlCol="0" anchor="ctr"/>
+          <a:lstStyle/>
+          <a:p>
+            <a:pPr algn="ctr" indent="0" marL="0">
+              <a:buNone/>
+            </a:pPr>
+            <a:r>
+              <a:rPr lang="en-US" sz="975" b="1" dirty="0">
+                <a:solidFill>
+                  <a:srgbClr val="15803D"/>
+                </a:solidFill>
+                <a:latin typeface="Segoe UI" pitchFamily="34" charset="0"/>
+                <a:ea typeface="Segoe UI" pitchFamily="34" charset="-122"/>
+                <a:cs typeface="Segoe UI" pitchFamily="34" charset="-120"/>
+              </a:rPr>
+              <a:t>2</a:t>
+            </a:r>
+            <a:endParaRPr lang="en-US" sz="975" dirty="0"/>
+          </a:p>
+        </p:txBody>
+      </p:sp>
+      <p:sp>
+        <p:nvSpPr>
+          <p:cNvPr id="10" name="Text 7"/>
+          <p:cNvSpPr/>
+          <p:nvPr/>
+        </p:nvSpPr>
+        <p:spPr>
+          <a:xfrm>
+            <a:off x="1222248" y="3956923"/>
+            <a:ext cx="4448556" cy="196882"/>
+          </a:xfrm>
+          <a:prstGeom prst="rect">
+            <a:avLst/>
+          </a:prstGeom>
+          <a:noFill/>
+          <a:ln/>
+        </p:spPr>
+        <p:txBody>
+          <a:bodyPr wrap="square" lIns="0" tIns="0" rIns="0" bIns="0" rtlCol="0" anchor="t"/>
+          <a:lstStyle/>
+          <a:p>
+            <a:pPr algn="l" indent="0" marL="0">
+              <a:lnSpc>
+                <a:spcPct val="115000"/>
+              </a:lnSpc>
+              <a:buNone/>
+            </a:pPr>
+            <a:r>
+              <a:rPr lang="en-US" sz="1125" dirty="0">
+                <a:solidFill>
+                  <a:srgbClr val="334155"/>
+                </a:solidFill>
+                <a:latin typeface="Segoe UI" pitchFamily="34" charset="0"/>
+                <a:ea typeface="Segoe UI" pitchFamily="34" charset="-122"/>
+                <a:cs typeface="Segoe UI" pitchFamily="34" charset="-120"/>
+              </a:rPr>
+              <a:t>Leave JDBC settings unchanged in DEVQA, SIT, and PROD</a:t>
+            </a:r>
+            <a:endParaRPr lang="en-US" sz="1125" dirty="0"/>
+          </a:p>
+        </p:txBody>
+      </p:sp>
+      <p:sp>
+        <p:nvSpPr>
+          <p:cNvPr id="11" name="Text 8"/>
+          <p:cNvSpPr/>
+          <p:nvPr/>
+        </p:nvSpPr>
+        <p:spPr>
+          <a:xfrm>
+            <a:off x="883920" y="4263533"/>
+            <a:ext cx="228600" cy="228600"/>
+          </a:xfrm>
+          <a:prstGeom prst="ellipse">
+            <a:avLst/>
+          </a:prstGeom>
+          <a:solidFill>
+            <a:srgbClr val="DCFCE7"/>
+          </a:solidFill>
+          <a:ln>
+            <a:solidFill>
+              <a:srgbClr val="DCFCE7"/>
+            </a:solidFill>
+          </a:ln>
+        </p:spPr>
+        <p:txBody>
+          <a:bodyPr wrap="square" lIns="0" tIns="0" rIns="0" bIns="0" rtlCol="0" anchor="ctr"/>
+          <a:lstStyle/>
+          <a:p>
+            <a:pPr algn="ctr" indent="0" marL="0">
+              <a:buNone/>
+            </a:pPr>
+            <a:r>
+              <a:rPr lang="en-US" sz="975" b="1" dirty="0">
+                <a:solidFill>
+                  <a:srgbClr val="15803D"/>
+                </a:solidFill>
+                <a:latin typeface="Segoe UI" pitchFamily="34" charset="0"/>
+                <a:ea typeface="Segoe UI" pitchFamily="34" charset="-122"/>
+                <a:cs typeface="Segoe UI" pitchFamily="34" charset="-120"/>
+              </a:rPr>
+              <a:t>3</a:t>
+            </a:r>
+            <a:endParaRPr lang="en-US" sz="975" dirty="0"/>
+          </a:p>
+        </p:txBody>
+      </p:sp>
+      <p:sp>
+        <p:nvSpPr>
+          <p:cNvPr id="12" name="Text 9"/>
+          <p:cNvSpPr/>
+          <p:nvPr/>
+        </p:nvSpPr>
+        <p:spPr>
+          <a:xfrm>
+            <a:off x="1222248" y="4290965"/>
+            <a:ext cx="4448556" cy="196882"/>
+          </a:xfrm>
+          <a:prstGeom prst="rect">
+            <a:avLst/>
+          </a:prstGeom>
+          <a:noFill/>
+          <a:ln/>
+        </p:spPr>
+        <p:txBody>
+          <a:bodyPr wrap="square" lIns="0" tIns="0" rIns="0" bIns="0" rtlCol="0" anchor="t"/>
+          <a:lstStyle/>
+          <a:p>
+            <a:pPr algn="l" indent="0" marL="0">
+              <a:lnSpc>
+                <a:spcPct val="115000"/>
+              </a:lnSpc>
+              <a:buNone/>
+            </a:pPr>
+            <a:r>
+              <a:rPr lang="en-US" sz="1125" dirty="0">
+                <a:solidFill>
+                  <a:srgbClr val="334155"/>
+                </a:solidFill>
+                <a:latin typeface="Segoe UI" pitchFamily="34" charset="0"/>
+                <a:ea typeface="Segoe UI" pitchFamily="34" charset="-122"/>
+                <a:cs typeface="Segoe UI" pitchFamily="34" charset="-120"/>
+              </a:rPr>
+              <a:t>Rebuild lis-patient-pmi-sync-svc. Its source stays the same</a:t>
+            </a:r>
+            <a:endParaRPr lang="en-US" sz="1125" dirty="0"/>
+          </a:p>
+        </p:txBody>
+      </p:sp>
+      <p:sp>
+        <p:nvSpPr>
+          <p:cNvPr id="13" name="Shape 10"/>
+          <p:cNvSpPr/>
+          <p:nvPr/>
+        </p:nvSpPr>
+        <p:spPr>
+          <a:xfrm>
+            <a:off x="6246876" y="2873073"/>
+            <a:ext cx="5335524" cy="2026253"/>
           </a:xfrm>
           <a:prstGeom prst="roundRect">
             <a:avLst>
-              <a:gd name="adj" fmla="val 5351"/>
+              <a:gd name="adj" fmla="val 5415"/>
             </a:avLst>
           </a:prstGeom>
           <a:solidFill>
@@ -4617,7 +4430,7 @@
       </p:sp>
       <p:pic>
         <p:nvPicPr>
-          <p:cNvPr id="9" name="Image 1" descr="D:\Github\HA-Notes\LIS\skills\design-review-pptx\assets\icons\png\accent\filter.png">    </p:cNvPr>
+          <p:cNvPr id="14" name="Image 1" descr="D:\Github\HA-Notes\LIS\skills\design-review-pptx\assets\icons\png\danger\rotate-left.png">    </p:cNvPr>
           <p:cNvPicPr>
             <a:picLocks noChangeAspect="1"/>
           </p:cNvPicPr>
@@ -4631,7 +4444,7 @@
         </p:blipFill>
         <p:spPr>
           <a:xfrm>
-            <a:off x="4617720" y="3180874"/>
+            <a:off x="6521196" y="3179397"/>
             <a:ext cx="265176" cy="265176"/>
           </a:xfrm>
           <a:prstGeom prst="rect">
@@ -4641,28 +4454,28 @@
       </p:pic>
       <p:sp>
         <p:nvSpPr>
-          <p:cNvPr id="10" name="Text 6"/>
-          <p:cNvSpPr/>
-          <p:nvPr/>
-        </p:nvSpPr>
-        <p:spPr>
-          <a:xfrm>
-            <a:off x="4617720" y="3638074"/>
-            <a:ext cx="2956560" cy="219075"/>
-          </a:xfrm>
-          <a:prstGeom prst="rect">
-            <a:avLst/>
-          </a:prstGeom>
-          <a:noFill/>
-          <a:ln/>
-        </p:spPr>
-        <p:txBody>
-          <a:bodyPr wrap="square" lIns="0" tIns="0" rIns="0" bIns="0" rtlCol="0" anchor="t"/>
+          <p:cNvPr id="15" name="Text 11"/>
+          <p:cNvSpPr/>
+          <p:nvPr/>
+        </p:nvSpPr>
+        <p:spPr>
+          <a:xfrm>
+            <a:off x="6886956" y="3165681"/>
+            <a:ext cx="4421124" cy="292608"/>
+          </a:xfrm>
+          <a:prstGeom prst="rect">
+            <a:avLst/>
+          </a:prstGeom>
+          <a:noFill/>
+          <a:ln/>
+        </p:spPr>
+        <p:txBody>
+          <a:bodyPr wrap="square" lIns="0" tIns="0" rIns="0" bIns="0" rtlCol="0" anchor="ctr"/>
           <a:lstStyle/>
           <a:p>
             <a:pPr algn="l" indent="0" marL="0">
               <a:lnSpc>
-                <a:spcPct val="110000"/>
+                <a:spcPct val="115000"/>
               </a:lnSpc>
               <a:buNone/>
             </a:pPr>
@@ -4675,7 +4488,7 @@
                 <a:ea typeface="Segoe UI Semibold" pitchFamily="34" charset="-122"/>
                 <a:cs typeface="Segoe UI Semibold" pitchFamily="34" charset="-120"/>
               </a:rPr>
-              <a:t>Sybase means replace</a:t>
+              <a:t>Fallback</a:t>
             </a:r>
             <a:endParaRPr lang="en-US" sz="1500" dirty="0"/>
           </a:p>
@@ -4683,107 +4496,59 @@
       </p:sp>
       <p:sp>
         <p:nvSpPr>
-          <p:cNvPr id="11" name="Text 7"/>
-          <p:cNvSpPr/>
-          <p:nvPr/>
-        </p:nvSpPr>
-        <p:spPr>
-          <a:xfrm>
-            <a:off x="4617720" y="3948589"/>
-            <a:ext cx="2956560" cy="798385"/>
-          </a:xfrm>
-          <a:prstGeom prst="rect">
-            <a:avLst/>
-          </a:prstGeom>
-          <a:noFill/>
-          <a:ln/>
-        </p:spPr>
-        <p:txBody>
-          <a:bodyPr wrap="square" lIns="0" tIns="0" rIns="0" bIns="0" rtlCol="0" anchor="t"/>
-          <a:lstStyle/>
-          <a:p>
-            <a:pPr algn="l" indent="0" marL="0">
-              <a:lnSpc>
-                <a:spcPct val="120000"/>
-              </a:lnSpc>
-              <a:buNone/>
-            </a:pPr>
-            <a:r>
-              <a:rPr lang="en-US" sz="1350" dirty="0">
-                <a:solidFill>
-                  <a:srgbClr val="475569"/>
+          <p:cNvPr id="16" name="Text 12"/>
+          <p:cNvSpPr/>
+          <p:nvPr/>
+        </p:nvSpPr>
+        <p:spPr>
+          <a:xfrm>
+            <a:off x="6521196" y="3595449"/>
+            <a:ext cx="228600" cy="228600"/>
+          </a:xfrm>
+          <a:prstGeom prst="ellipse">
+            <a:avLst/>
+          </a:prstGeom>
+          <a:solidFill>
+            <a:srgbClr val="FEE2E2"/>
+          </a:solidFill>
+          <a:ln>
+            <a:solidFill>
+              <a:srgbClr val="FEE2E2"/>
+            </a:solidFill>
+          </a:ln>
+        </p:spPr>
+        <p:txBody>
+          <a:bodyPr wrap="square" lIns="0" tIns="0" rIns="0" bIns="0" rtlCol="0" anchor="ctr"/>
+          <a:lstStyle/>
+          <a:p>
+            <a:pPr algn="ctr" indent="0" marL="0">
+              <a:buNone/>
+            </a:pPr>
+            <a:r>
+              <a:rPr lang="en-US" sz="975" b="1" dirty="0">
+                <a:solidFill>
+                  <a:srgbClr val="B91C1C"/>
                 </a:solidFill>
                 <a:latin typeface="Segoe UI" pitchFamily="34" charset="0"/>
                 <a:ea typeface="Segoe UI" pitchFamily="34" charset="-122"/>
                 <a:cs typeface="Segoe UI" pitchFamily="34" charset="-120"/>
               </a:rPr>
-              <a:t>If the flag says the hospital is Sybase, replace the Chinese characters.</a:t>
-            </a:r>
-            <a:endParaRPr lang="en-US" sz="1350" dirty="0"/>
-          </a:p>
-        </p:txBody>
-      </p:sp>
-      <p:sp>
-        <p:nvSpPr>
-          <p:cNvPr id="12" name="Shape 8"/>
-          <p:cNvSpPr/>
-          <p:nvPr/>
-        </p:nvSpPr>
-        <p:spPr>
-          <a:xfrm>
-            <a:off x="8077200" y="2860834"/>
-            <a:ext cx="3505200" cy="2050732"/>
-          </a:xfrm>
-          <a:prstGeom prst="roundRect">
-            <a:avLst>
-              <a:gd name="adj" fmla="val 5351"/>
-            </a:avLst>
-          </a:prstGeom>
-          <a:solidFill>
-            <a:srgbClr val="FFFFFF"/>
-          </a:solidFill>
-          <a:ln w="9525">
-            <a:solidFill>
-              <a:srgbClr val="E2E8F0"/>
-            </a:solidFill>
-            <a:prstDash val="solid"/>
-          </a:ln>
-        </p:spPr>
-      </p:sp>
-      <p:pic>
-        <p:nvPicPr>
-          <p:cNvPr id="13" name="Image 2" descr="D:\Github\HA-Notes\LIS\skills\design-review-pptx\assets\icons\png\accent\hospital.png">    </p:cNvPr>
-          <p:cNvPicPr>
-            <a:picLocks noChangeAspect="1"/>
-          </p:cNvPicPr>
-          <p:nvPr/>
-        </p:nvPicPr>
-        <p:blipFill>
-          <a:blip r:embed="rId3"/>
-          <a:stretch>
-            <a:fillRect/>
-          </a:stretch>
-        </p:blipFill>
-        <p:spPr>
-          <a:xfrm>
-            <a:off x="8351520" y="3180874"/>
-            <a:ext cx="265176" cy="265176"/>
-          </a:xfrm>
-          <a:prstGeom prst="rect">
-            <a:avLst/>
-          </a:prstGeom>
-        </p:spPr>
-      </p:pic>
-      <p:sp>
-        <p:nvSpPr>
-          <p:cNvPr id="14" name="Text 9"/>
-          <p:cNvSpPr/>
-          <p:nvPr/>
-        </p:nvSpPr>
-        <p:spPr>
-          <a:xfrm>
-            <a:off x="8351520" y="3638074"/>
-            <a:ext cx="2956560" cy="219075"/>
+              <a:t>1</a:t>
+            </a:r>
+            <a:endParaRPr lang="en-US" sz="975" dirty="0"/>
+          </a:p>
+        </p:txBody>
+      </p:sp>
+      <p:sp>
+        <p:nvSpPr>
+          <p:cNvPr id="17" name="Text 13"/>
+          <p:cNvSpPr/>
+          <p:nvPr/>
+        </p:nvSpPr>
+        <p:spPr>
+          <a:xfrm>
+            <a:off x="6859524" y="3622881"/>
+            <a:ext cx="4448556" cy="196882"/>
           </a:xfrm>
           <a:prstGeom prst="rect">
             <a:avLst/>
@@ -4797,64 +4562,196 @@
           <a:p>
             <a:pPr algn="l" indent="0" marL="0">
               <a:lnSpc>
-                <a:spcPct val="110000"/>
+                <a:spcPct val="115000"/>
               </a:lnSpc>
               <a:buNone/>
             </a:pPr>
             <a:r>
-              <a:rPr lang="en-US" sz="1500" dirty="0">
-                <a:solidFill>
-                  <a:srgbClr val="0F172A"/>
-                </a:solidFill>
-                <a:latin typeface="Segoe UI Semibold" pitchFamily="34" charset="0"/>
-                <a:ea typeface="Segoe UI Semibold" pitchFamily="34" charset="-122"/>
-                <a:cs typeface="Segoe UI Semibold" pitchFamily="34" charset="-120"/>
-              </a:rPr>
-              <a:t>Hospital work stays open</a:t>
-            </a:r>
-            <a:endParaRPr lang="en-US" sz="1500" dirty="0"/>
-          </a:p>
-        </p:txBody>
-      </p:sp>
-      <p:sp>
-        <p:nvSpPr>
-          <p:cNvPr id="15" name="Text 10"/>
-          <p:cNvSpPr/>
-          <p:nvPr/>
-        </p:nvSpPr>
-        <p:spPr>
-          <a:xfrm>
-            <a:off x="8351520" y="3948589"/>
-            <a:ext cx="2956560" cy="798385"/>
-          </a:xfrm>
-          <a:prstGeom prst="rect">
-            <a:avLst/>
-          </a:prstGeom>
-          <a:noFill/>
-          <a:ln/>
-        </p:spPr>
-        <p:txBody>
-          <a:bodyPr wrap="square" lIns="0" tIns="0" rIns="0" bIns="0" rtlCol="0" anchor="t"/>
-          <a:lstStyle/>
-          <a:p>
-            <a:pPr algn="l" indent="0" marL="0">
-              <a:lnSpc>
-                <a:spcPct val="120000"/>
-              </a:lnSpc>
-              <a:buNone/>
-            </a:pPr>
-            <a:r>
-              <a:rPr lang="en-US" sz="1350" dirty="0">
-                <a:solidFill>
-                  <a:srgbClr val="475569"/>
+              <a:rPr lang="en-US" sz="1125" dirty="0">
+                <a:solidFill>
+                  <a:srgbClr val="334155"/>
                 </a:solidFill>
                 <a:latin typeface="Segoe UI" pitchFamily="34" charset="0"/>
                 <a:ea typeface="Segoe UI" pitchFamily="34" charset="-122"/>
                 <a:cs typeface="Segoe UI" pitchFamily="34" charset="-120"/>
               </a:rPr>
-              <a:t>Do not switch the hospital transaction over to Oracle.</a:t>
-            </a:r>
-            <a:endParaRPr lang="en-US" sz="1350" dirty="0"/>
+              <a:t>Redeploy the previous data-source build and restart</a:t>
+            </a:r>
+            <a:endParaRPr lang="en-US" sz="1125" dirty="0"/>
+          </a:p>
+        </p:txBody>
+      </p:sp>
+      <p:sp>
+        <p:nvSpPr>
+          <p:cNvPr id="18" name="Text 14"/>
+          <p:cNvSpPr/>
+          <p:nvPr/>
+        </p:nvSpPr>
+        <p:spPr>
+          <a:xfrm>
+            <a:off x="6521196" y="3929491"/>
+            <a:ext cx="228600" cy="228600"/>
+          </a:xfrm>
+          <a:prstGeom prst="ellipse">
+            <a:avLst/>
+          </a:prstGeom>
+          <a:solidFill>
+            <a:srgbClr val="FEE2E2"/>
+          </a:solidFill>
+          <a:ln>
+            <a:solidFill>
+              <a:srgbClr val="FEE2E2"/>
+            </a:solidFill>
+          </a:ln>
+        </p:spPr>
+        <p:txBody>
+          <a:bodyPr wrap="square" lIns="0" tIns="0" rIns="0" bIns="0" rtlCol="0" anchor="ctr"/>
+          <a:lstStyle/>
+          <a:p>
+            <a:pPr algn="ctr" indent="0" marL="0">
+              <a:buNone/>
+            </a:pPr>
+            <a:r>
+              <a:rPr lang="en-US" sz="975" b="1" dirty="0">
+                <a:solidFill>
+                  <a:srgbClr val="B91C1C"/>
+                </a:solidFill>
+                <a:latin typeface="Segoe UI" pitchFamily="34" charset="0"/>
+                <a:ea typeface="Segoe UI" pitchFamily="34" charset="-122"/>
+                <a:cs typeface="Segoe UI" pitchFamily="34" charset="-120"/>
+              </a:rPr>
+              <a:t>2</a:t>
+            </a:r>
+            <a:endParaRPr lang="en-US" sz="975" dirty="0"/>
+          </a:p>
+        </p:txBody>
+      </p:sp>
+      <p:sp>
+        <p:nvSpPr>
+          <p:cNvPr id="19" name="Text 15"/>
+          <p:cNvSpPr/>
+          <p:nvPr/>
+        </p:nvSpPr>
+        <p:spPr>
+          <a:xfrm>
+            <a:off x="6859524" y="3956923"/>
+            <a:ext cx="4448556" cy="196882"/>
+          </a:xfrm>
+          <a:prstGeom prst="rect">
+            <a:avLst/>
+          </a:prstGeom>
+          <a:noFill/>
+          <a:ln/>
+        </p:spPr>
+        <p:txBody>
+          <a:bodyPr wrap="square" lIns="0" tIns="0" rIns="0" bIns="0" rtlCol="0" anchor="t"/>
+          <a:lstStyle/>
+          <a:p>
+            <a:pPr algn="l" indent="0" marL="0">
+              <a:lnSpc>
+                <a:spcPct val="115000"/>
+              </a:lnSpc>
+              <a:buNone/>
+            </a:pPr>
+            <a:r>
+              <a:rPr lang="en-US" sz="1125" dirty="0">
+                <a:solidFill>
+                  <a:srgbClr val="334155"/>
+                </a:solidFill>
+                <a:latin typeface="Segoe UI" pitchFamily="34" charset="0"/>
+                <a:ea typeface="Segoe UI" pitchFamily="34" charset="-122"/>
+                <a:cs typeface="Segoe UI" pitchFamily="34" charset="-120"/>
+              </a:rPr>
+              <a:t>On Sybase, the log says defaulting to PostgreSQL</a:t>
+            </a:r>
+            <a:endParaRPr lang="en-US" sz="1125" dirty="0"/>
+          </a:p>
+        </p:txBody>
+      </p:sp>
+      <p:sp>
+        <p:nvSpPr>
+          <p:cNvPr id="20" name="Text 16"/>
+          <p:cNvSpPr/>
+          <p:nvPr/>
+        </p:nvSpPr>
+        <p:spPr>
+          <a:xfrm>
+            <a:off x="6521196" y="4263533"/>
+            <a:ext cx="228600" cy="228600"/>
+          </a:xfrm>
+          <a:prstGeom prst="ellipse">
+            <a:avLst/>
+          </a:prstGeom>
+          <a:solidFill>
+            <a:srgbClr val="FEE2E2"/>
+          </a:solidFill>
+          <a:ln>
+            <a:solidFill>
+              <a:srgbClr val="FEE2E2"/>
+            </a:solidFill>
+          </a:ln>
+        </p:spPr>
+        <p:txBody>
+          <a:bodyPr wrap="square" lIns="0" tIns="0" rIns="0" bIns="0" rtlCol="0" anchor="ctr"/>
+          <a:lstStyle/>
+          <a:p>
+            <a:pPr algn="ctr" indent="0" marL="0">
+              <a:buNone/>
+            </a:pPr>
+            <a:r>
+              <a:rPr lang="en-US" sz="975" b="1" dirty="0">
+                <a:solidFill>
+                  <a:srgbClr val="B91C1C"/>
+                </a:solidFill>
+                <a:latin typeface="Segoe UI" pitchFamily="34" charset="0"/>
+                <a:ea typeface="Segoe UI" pitchFamily="34" charset="-122"/>
+                <a:cs typeface="Segoe UI" pitchFamily="34" charset="-120"/>
+              </a:rPr>
+              <a:t>3</a:t>
+            </a:r>
+            <a:endParaRPr lang="en-US" sz="975" dirty="0"/>
+          </a:p>
+        </p:txBody>
+      </p:sp>
+      <p:sp>
+        <p:nvSpPr>
+          <p:cNvPr id="21" name="Text 17"/>
+          <p:cNvSpPr/>
+          <p:nvPr/>
+        </p:nvSpPr>
+        <p:spPr>
+          <a:xfrm>
+            <a:off x="6859524" y="4290965"/>
+            <a:ext cx="4448556" cy="196882"/>
+          </a:xfrm>
+          <a:prstGeom prst="rect">
+            <a:avLst/>
+          </a:prstGeom>
+          <a:noFill/>
+          <a:ln/>
+        </p:spPr>
+        <p:txBody>
+          <a:bodyPr wrap="square" lIns="0" tIns="0" rIns="0" bIns="0" rtlCol="0" anchor="t"/>
+          <a:lstStyle/>
+          <a:p>
+            <a:pPr algn="l" indent="0" marL="0">
+              <a:lnSpc>
+                <a:spcPct val="115000"/>
+              </a:lnSpc>
+              <a:buNone/>
+            </a:pPr>
+            <a:r>
+              <a:rPr lang="en-US" sz="1125" dirty="0">
+                <a:solidFill>
+                  <a:srgbClr val="334155"/>
+                </a:solidFill>
+                <a:latin typeface="Segoe UI" pitchFamily="34" charset="0"/>
+                <a:ea typeface="Segoe UI" pitchFamily="34" charset="-122"/>
+                <a:cs typeface="Segoe UI" pitchFamily="34" charset="-120"/>
+              </a:rPr>
+              <a:t>Drop one cached type check for that hospital and lab</a:t>
+            </a:r>
+            <a:endParaRPr lang="en-US" sz="1125" dirty="0"/>
           </a:p>
         </p:txBody>
       </p:sp>
@@ -4869,824 +4766,6 @@
 <file path=ppt/slides/slide6.xml><?xml version="1.0" encoding="utf-8"?>
 <p:sld xmlns:a="http://schemas.openxmlformats.org/drawingml/2006/main" xmlns:r="http://schemas.openxmlformats.org/officeDocument/2006/relationships" xmlns:p="http://schemas.openxmlformats.org/presentationml/2006/main">
   <p:cSld name="Slide 6">
-    <p:bg>
-      <p:bgPr>
-        <a:solidFill>
-          <a:srgbClr val="F8FAFC"/>
-        </a:solidFill>
-      </p:bgPr>
-    </p:bg>
-    <p:spTree>
-      <p:nvGrpSpPr>
-        <p:cNvPr id="1" name=""/>
-        <p:cNvGrpSpPr/>
-        <p:nvPr/>
-      </p:nvGrpSpPr>
-      <p:grpSpPr>
-        <a:xfrm>
-          <a:off x="0" y="0"/>
-          <a:ext cx="0" cy="0"/>
-          <a:chOff x="0" y="0"/>
-          <a:chExt cx="0" cy="0"/>
-        </a:xfrm>
-      </p:grpSpPr>
-      <p:sp>
-        <p:nvSpPr>
-          <p:cNvPr id="2" name="Text 0"/>
-          <p:cNvSpPr/>
-          <p:nvPr/>
-        </p:nvSpPr>
-        <p:spPr>
-          <a:xfrm>
-            <a:off x="609600" y="457200"/>
-            <a:ext cx="10972800" cy="228600"/>
-          </a:xfrm>
-          <a:prstGeom prst="rect">
-            <a:avLst/>
-          </a:prstGeom>
-          <a:noFill/>
-          <a:ln/>
-        </p:spPr>
-        <p:txBody>
-          <a:bodyPr wrap="square" lIns="0" tIns="0" rIns="0" bIns="0" rtlCol="0" anchor="ctr"/>
-          <a:lstStyle/>
-          <a:p>
-            <a:pPr indent="0" marL="0">
-              <a:buNone/>
-            </a:pPr>
-            <a:r>
-              <a:rPr lang="en-US" sz="1050" spc="150" kern="0" dirty="0">
-                <a:solidFill>
-                  <a:srgbClr val="0284C7"/>
-                </a:solidFill>
-                <a:latin typeface="Segoe UI Semibold" pitchFamily="34" charset="0"/>
-                <a:ea typeface="Segoe UI Semibold" pitchFamily="34" charset="-122"/>
-                <a:cs typeface="Segoe UI Semibold" pitchFamily="34" charset="-120"/>
-              </a:rPr>
-              <a:t>PROMOTION AND FALLBACK</a:t>
-            </a:r>
-            <a:endParaRPr lang="en-US" sz="1050" dirty="0"/>
-          </a:p>
-        </p:txBody>
-      </p:sp>
-      <p:sp>
-        <p:nvSpPr>
-          <p:cNvPr id="3" name="Text 1"/>
-          <p:cNvSpPr/>
-          <p:nvPr/>
-        </p:nvSpPr>
-        <p:spPr>
-          <a:xfrm>
-            <a:off x="609600" y="722376"/>
-            <a:ext cx="10972800" cy="457200"/>
-          </a:xfrm>
-          <a:prstGeom prst="rect">
-            <a:avLst/>
-          </a:prstGeom>
-          <a:noFill/>
-          <a:ln/>
-        </p:spPr>
-        <p:txBody>
-          <a:bodyPr wrap="square" lIns="0" tIns="0" rIns="0" bIns="0" rtlCol="0" anchor="ctr"/>
-          <a:lstStyle/>
-          <a:p>
-            <a:pPr indent="0" marL="0">
-              <a:buNone/>
-            </a:pPr>
-            <a:r>
-              <a:rPr lang="en-US" sz="2400" dirty="0">
-                <a:solidFill>
-                  <a:srgbClr val="0F172A"/>
-                </a:solidFill>
-                <a:latin typeface="Segoe UI Semibold" pitchFamily="34" charset="0"/>
-                <a:ea typeface="Segoe UI Semibold" pitchFamily="34" charset="-122"/>
-                <a:cs typeface="Segoe UI Semibold" pitchFamily="34" charset="-120"/>
-              </a:rPr>
-              <a:t>Ship the new library, or put the previous one back</a:t>
-            </a:r>
-            <a:endParaRPr lang="en-US" sz="2400" dirty="0"/>
-          </a:p>
-        </p:txBody>
-      </p:sp>
-      <p:sp>
-        <p:nvSpPr>
-          <p:cNvPr id="4" name="Shape 2"/>
-          <p:cNvSpPr/>
-          <p:nvPr/>
-        </p:nvSpPr>
-        <p:spPr>
-          <a:xfrm>
-            <a:off x="609600" y="2873073"/>
-            <a:ext cx="5335524" cy="2026253"/>
-          </a:xfrm>
-          <a:prstGeom prst="roundRect">
-            <a:avLst>
-              <a:gd name="adj" fmla="val 5415"/>
-            </a:avLst>
-          </a:prstGeom>
-          <a:solidFill>
-            <a:srgbClr val="FFFFFF"/>
-          </a:solidFill>
-          <a:ln w="9525">
-            <a:solidFill>
-              <a:srgbClr val="E2E8F0"/>
-            </a:solidFill>
-            <a:prstDash val="solid"/>
-          </a:ln>
-        </p:spPr>
-      </p:sp>
-      <p:pic>
-        <p:nvPicPr>
-          <p:cNvPr id="5" name="Image 0" descr="D:\Github\HA-Notes\LIS\skills\design-review-pptx\assets\icons\png\success\cloud-arrow-up.png">    </p:cNvPr>
-          <p:cNvPicPr>
-            <a:picLocks noChangeAspect="1"/>
-          </p:cNvPicPr>
-          <p:nvPr/>
-        </p:nvPicPr>
-        <p:blipFill>
-          <a:blip r:embed="rId1"/>
-          <a:stretch>
-            <a:fillRect/>
-          </a:stretch>
-        </p:blipFill>
-        <p:spPr>
-          <a:xfrm>
-            <a:off x="883920" y="3179397"/>
-            <a:ext cx="265176" cy="265176"/>
-          </a:xfrm>
-          <a:prstGeom prst="rect">
-            <a:avLst/>
-          </a:prstGeom>
-        </p:spPr>
-      </p:pic>
-      <p:sp>
-        <p:nvSpPr>
-          <p:cNvPr id="6" name="Text 3"/>
-          <p:cNvSpPr/>
-          <p:nvPr/>
-        </p:nvSpPr>
-        <p:spPr>
-          <a:xfrm>
-            <a:off x="1249680" y="3165681"/>
-            <a:ext cx="4421124" cy="292608"/>
-          </a:xfrm>
-          <a:prstGeom prst="rect">
-            <a:avLst/>
-          </a:prstGeom>
-          <a:noFill/>
-          <a:ln/>
-        </p:spPr>
-        <p:txBody>
-          <a:bodyPr wrap="square" lIns="0" tIns="0" rIns="0" bIns="0" rtlCol="0" anchor="ctr"/>
-          <a:lstStyle/>
-          <a:p>
-            <a:pPr algn="l" indent="0" marL="0">
-              <a:lnSpc>
-                <a:spcPct val="115000"/>
-              </a:lnSpc>
-              <a:buNone/>
-            </a:pPr>
-            <a:r>
-              <a:rPr lang="en-US" sz="1500" dirty="0">
-                <a:solidFill>
-                  <a:srgbClr val="0F172A"/>
-                </a:solidFill>
-                <a:latin typeface="Segoe UI Semibold" pitchFamily="34" charset="0"/>
-                <a:ea typeface="Segoe UI Semibold" pitchFamily="34" charset="-122"/>
-                <a:cs typeface="Segoe UI Semibold" pitchFamily="34" charset="-120"/>
-              </a:rPr>
-              <a:t>Promotion</a:t>
-            </a:r>
-            <a:endParaRPr lang="en-US" sz="1500" dirty="0"/>
-          </a:p>
-        </p:txBody>
-      </p:sp>
-      <p:sp>
-        <p:nvSpPr>
-          <p:cNvPr id="7" name="Text 4"/>
-          <p:cNvSpPr/>
-          <p:nvPr/>
-        </p:nvSpPr>
-        <p:spPr>
-          <a:xfrm>
-            <a:off x="883920" y="3595449"/>
-            <a:ext cx="228600" cy="228600"/>
-          </a:xfrm>
-          <a:prstGeom prst="ellipse">
-            <a:avLst/>
-          </a:prstGeom>
-          <a:solidFill>
-            <a:srgbClr val="DCFCE7"/>
-          </a:solidFill>
-          <a:ln>
-            <a:solidFill>
-              <a:srgbClr val="DCFCE7"/>
-            </a:solidFill>
-          </a:ln>
-        </p:spPr>
-        <p:txBody>
-          <a:bodyPr wrap="square" lIns="0" tIns="0" rIns="0" bIns="0" rtlCol="0" anchor="ctr"/>
-          <a:lstStyle/>
-          <a:p>
-            <a:pPr algn="ctr" indent="0" marL="0">
-              <a:buNone/>
-            </a:pPr>
-            <a:r>
-              <a:rPr lang="en-US" sz="975" b="1" dirty="0">
-                <a:solidFill>
-                  <a:srgbClr val="15803D"/>
-                </a:solidFill>
-                <a:latin typeface="Segoe UI" pitchFamily="34" charset="0"/>
-                <a:ea typeface="Segoe UI" pitchFamily="34" charset="-122"/>
-                <a:cs typeface="Segoe UI" pitchFamily="34" charset="-120"/>
-              </a:rPr>
-              <a:t>1</a:t>
-            </a:r>
-            <a:endParaRPr lang="en-US" sz="975" dirty="0"/>
-          </a:p>
-        </p:txBody>
-      </p:sp>
-      <p:sp>
-        <p:nvSpPr>
-          <p:cNvPr id="8" name="Text 5"/>
-          <p:cNvSpPr/>
-          <p:nvPr/>
-        </p:nvSpPr>
-        <p:spPr>
-          <a:xfrm>
-            <a:off x="1222248" y="3622881"/>
-            <a:ext cx="4448556" cy="196882"/>
-          </a:xfrm>
-          <a:prstGeom prst="rect">
-            <a:avLst/>
-          </a:prstGeom>
-          <a:noFill/>
-          <a:ln/>
-        </p:spPr>
-        <p:txBody>
-          <a:bodyPr wrap="square" lIns="0" tIns="0" rIns="0" bIns="0" rtlCol="0" anchor="t"/>
-          <a:lstStyle/>
-          <a:p>
-            <a:pPr algn="l" indent="0" marL="0">
-              <a:lnSpc>
-                <a:spcPct val="115000"/>
-              </a:lnSpc>
-              <a:buNone/>
-            </a:pPr>
-            <a:r>
-              <a:rPr lang="en-US" sz="1125" dirty="0">
-                <a:solidFill>
-                  <a:srgbClr val="334155"/>
-                </a:solidFill>
-                <a:latin typeface="Segoe UI" pitchFamily="34" charset="0"/>
-                <a:ea typeface="Segoe UI" pitchFamily="34" charset="-122"/>
-                <a:cs typeface="Segoe UI" pitchFamily="34" charset="-120"/>
-              </a:rPr>
-              <a:t>Ship a new data-source build</a:t>
-            </a:r>
-            <a:endParaRPr lang="en-US" sz="1125" dirty="0"/>
-          </a:p>
-        </p:txBody>
-      </p:sp>
-      <p:sp>
-        <p:nvSpPr>
-          <p:cNvPr id="9" name="Text 6"/>
-          <p:cNvSpPr/>
-          <p:nvPr/>
-        </p:nvSpPr>
-        <p:spPr>
-          <a:xfrm>
-            <a:off x="883920" y="3929491"/>
-            <a:ext cx="228600" cy="228600"/>
-          </a:xfrm>
-          <a:prstGeom prst="ellipse">
-            <a:avLst/>
-          </a:prstGeom>
-          <a:solidFill>
-            <a:srgbClr val="DCFCE7"/>
-          </a:solidFill>
-          <a:ln>
-            <a:solidFill>
-              <a:srgbClr val="DCFCE7"/>
-            </a:solidFill>
-          </a:ln>
-        </p:spPr>
-        <p:txBody>
-          <a:bodyPr wrap="square" lIns="0" tIns="0" rIns="0" bIns="0" rtlCol="0" anchor="ctr"/>
-          <a:lstStyle/>
-          <a:p>
-            <a:pPr algn="ctr" indent="0" marL="0">
-              <a:buNone/>
-            </a:pPr>
-            <a:r>
-              <a:rPr lang="en-US" sz="975" b="1" dirty="0">
-                <a:solidFill>
-                  <a:srgbClr val="15803D"/>
-                </a:solidFill>
-                <a:latin typeface="Segoe UI" pitchFamily="34" charset="0"/>
-                <a:ea typeface="Segoe UI" pitchFamily="34" charset="-122"/>
-                <a:cs typeface="Segoe UI" pitchFamily="34" charset="-120"/>
-              </a:rPr>
-              <a:t>2</a:t>
-            </a:r>
-            <a:endParaRPr lang="en-US" sz="975" dirty="0"/>
-          </a:p>
-        </p:txBody>
-      </p:sp>
-      <p:sp>
-        <p:nvSpPr>
-          <p:cNvPr id="10" name="Text 7"/>
-          <p:cNvSpPr/>
-          <p:nvPr/>
-        </p:nvSpPr>
-        <p:spPr>
-          <a:xfrm>
-            <a:off x="1222248" y="3956923"/>
-            <a:ext cx="4448556" cy="196882"/>
-          </a:xfrm>
-          <a:prstGeom prst="rect">
-            <a:avLst/>
-          </a:prstGeom>
-          <a:noFill/>
-          <a:ln/>
-        </p:spPr>
-        <p:txBody>
-          <a:bodyPr wrap="square" lIns="0" tIns="0" rIns="0" bIns="0" rtlCol="0" anchor="t"/>
-          <a:lstStyle/>
-          <a:p>
-            <a:pPr algn="l" indent="0" marL="0">
-              <a:lnSpc>
-                <a:spcPct val="115000"/>
-              </a:lnSpc>
-              <a:buNone/>
-            </a:pPr>
-            <a:r>
-              <a:rPr lang="en-US" sz="1125" dirty="0">
-                <a:solidFill>
-                  <a:srgbClr val="334155"/>
-                </a:solidFill>
-                <a:latin typeface="Segoe UI" pitchFamily="34" charset="0"/>
-                <a:ea typeface="Segoe UI" pitchFamily="34" charset="-122"/>
-                <a:cs typeface="Segoe UI" pitchFamily="34" charset="-120"/>
-              </a:rPr>
-              <a:t>Leave JDBC settings unchanged in DEVQA, SIT, and PROD</a:t>
-            </a:r>
-            <a:endParaRPr lang="en-US" sz="1125" dirty="0"/>
-          </a:p>
-        </p:txBody>
-      </p:sp>
-      <p:sp>
-        <p:nvSpPr>
-          <p:cNvPr id="11" name="Text 8"/>
-          <p:cNvSpPr/>
-          <p:nvPr/>
-        </p:nvSpPr>
-        <p:spPr>
-          <a:xfrm>
-            <a:off x="883920" y="4263533"/>
-            <a:ext cx="228600" cy="228600"/>
-          </a:xfrm>
-          <a:prstGeom prst="ellipse">
-            <a:avLst/>
-          </a:prstGeom>
-          <a:solidFill>
-            <a:srgbClr val="DCFCE7"/>
-          </a:solidFill>
-          <a:ln>
-            <a:solidFill>
-              <a:srgbClr val="DCFCE7"/>
-            </a:solidFill>
-          </a:ln>
-        </p:spPr>
-        <p:txBody>
-          <a:bodyPr wrap="square" lIns="0" tIns="0" rIns="0" bIns="0" rtlCol="0" anchor="ctr"/>
-          <a:lstStyle/>
-          <a:p>
-            <a:pPr algn="ctr" indent="0" marL="0">
-              <a:buNone/>
-            </a:pPr>
-            <a:r>
-              <a:rPr lang="en-US" sz="975" b="1" dirty="0">
-                <a:solidFill>
-                  <a:srgbClr val="15803D"/>
-                </a:solidFill>
-                <a:latin typeface="Segoe UI" pitchFamily="34" charset="0"/>
-                <a:ea typeface="Segoe UI" pitchFamily="34" charset="-122"/>
-                <a:cs typeface="Segoe UI" pitchFamily="34" charset="-120"/>
-              </a:rPr>
-              <a:t>3</a:t>
-            </a:r>
-            <a:endParaRPr lang="en-US" sz="975" dirty="0"/>
-          </a:p>
-        </p:txBody>
-      </p:sp>
-      <p:sp>
-        <p:nvSpPr>
-          <p:cNvPr id="12" name="Text 9"/>
-          <p:cNvSpPr/>
-          <p:nvPr/>
-        </p:nvSpPr>
-        <p:spPr>
-          <a:xfrm>
-            <a:off x="1222248" y="4290965"/>
-            <a:ext cx="4448556" cy="196882"/>
-          </a:xfrm>
-          <a:prstGeom prst="rect">
-            <a:avLst/>
-          </a:prstGeom>
-          <a:noFill/>
-          <a:ln/>
-        </p:spPr>
-        <p:txBody>
-          <a:bodyPr wrap="square" lIns="0" tIns="0" rIns="0" bIns="0" rtlCol="0" anchor="t"/>
-          <a:lstStyle/>
-          <a:p>
-            <a:pPr algn="l" indent="0" marL="0">
-              <a:lnSpc>
-                <a:spcPct val="115000"/>
-              </a:lnSpc>
-              <a:buNone/>
-            </a:pPr>
-            <a:r>
-              <a:rPr lang="en-US" sz="1125" dirty="0">
-                <a:solidFill>
-                  <a:srgbClr val="334155"/>
-                </a:solidFill>
-                <a:latin typeface="Segoe UI" pitchFamily="34" charset="0"/>
-                <a:ea typeface="Segoe UI" pitchFamily="34" charset="-122"/>
-                <a:cs typeface="Segoe UI" pitchFamily="34" charset="-120"/>
-              </a:rPr>
-              <a:t>Rebuild lis-patient-pmi-sync-svc. Its source stays the same</a:t>
-            </a:r>
-            <a:endParaRPr lang="en-US" sz="1125" dirty="0"/>
-          </a:p>
-        </p:txBody>
-      </p:sp>
-      <p:sp>
-        <p:nvSpPr>
-          <p:cNvPr id="13" name="Shape 10"/>
-          <p:cNvSpPr/>
-          <p:nvPr/>
-        </p:nvSpPr>
-        <p:spPr>
-          <a:xfrm>
-            <a:off x="6246876" y="2873073"/>
-            <a:ext cx="5335524" cy="2026253"/>
-          </a:xfrm>
-          <a:prstGeom prst="roundRect">
-            <a:avLst>
-              <a:gd name="adj" fmla="val 5415"/>
-            </a:avLst>
-          </a:prstGeom>
-          <a:solidFill>
-            <a:srgbClr val="FFFFFF"/>
-          </a:solidFill>
-          <a:ln w="9525">
-            <a:solidFill>
-              <a:srgbClr val="E2E8F0"/>
-            </a:solidFill>
-            <a:prstDash val="solid"/>
-          </a:ln>
-        </p:spPr>
-      </p:sp>
-      <p:pic>
-        <p:nvPicPr>
-          <p:cNvPr id="14" name="Image 1" descr="D:\Github\HA-Notes\LIS\skills\design-review-pptx\assets\icons\png\danger\rotate-left.png">    </p:cNvPr>
-          <p:cNvPicPr>
-            <a:picLocks noChangeAspect="1"/>
-          </p:cNvPicPr>
-          <p:nvPr/>
-        </p:nvPicPr>
-        <p:blipFill>
-          <a:blip r:embed="rId2"/>
-          <a:stretch>
-            <a:fillRect/>
-          </a:stretch>
-        </p:blipFill>
-        <p:spPr>
-          <a:xfrm>
-            <a:off x="6521196" y="3179397"/>
-            <a:ext cx="265176" cy="265176"/>
-          </a:xfrm>
-          <a:prstGeom prst="rect">
-            <a:avLst/>
-          </a:prstGeom>
-        </p:spPr>
-      </p:pic>
-      <p:sp>
-        <p:nvSpPr>
-          <p:cNvPr id="15" name="Text 11"/>
-          <p:cNvSpPr/>
-          <p:nvPr/>
-        </p:nvSpPr>
-        <p:spPr>
-          <a:xfrm>
-            <a:off x="6886956" y="3165681"/>
-            <a:ext cx="4421124" cy="292608"/>
-          </a:xfrm>
-          <a:prstGeom prst="rect">
-            <a:avLst/>
-          </a:prstGeom>
-          <a:noFill/>
-          <a:ln/>
-        </p:spPr>
-        <p:txBody>
-          <a:bodyPr wrap="square" lIns="0" tIns="0" rIns="0" bIns="0" rtlCol="0" anchor="ctr"/>
-          <a:lstStyle/>
-          <a:p>
-            <a:pPr algn="l" indent="0" marL="0">
-              <a:lnSpc>
-                <a:spcPct val="115000"/>
-              </a:lnSpc>
-              <a:buNone/>
-            </a:pPr>
-            <a:r>
-              <a:rPr lang="en-US" sz="1500" dirty="0">
-                <a:solidFill>
-                  <a:srgbClr val="0F172A"/>
-                </a:solidFill>
-                <a:latin typeface="Segoe UI Semibold" pitchFamily="34" charset="0"/>
-                <a:ea typeface="Segoe UI Semibold" pitchFamily="34" charset="-122"/>
-                <a:cs typeface="Segoe UI Semibold" pitchFamily="34" charset="-120"/>
-              </a:rPr>
-              <a:t>Fallback</a:t>
-            </a:r>
-            <a:endParaRPr lang="en-US" sz="1500" dirty="0"/>
-          </a:p>
-        </p:txBody>
-      </p:sp>
-      <p:sp>
-        <p:nvSpPr>
-          <p:cNvPr id="16" name="Text 12"/>
-          <p:cNvSpPr/>
-          <p:nvPr/>
-        </p:nvSpPr>
-        <p:spPr>
-          <a:xfrm>
-            <a:off x="6521196" y="3595449"/>
-            <a:ext cx="228600" cy="228600"/>
-          </a:xfrm>
-          <a:prstGeom prst="ellipse">
-            <a:avLst/>
-          </a:prstGeom>
-          <a:solidFill>
-            <a:srgbClr val="FEE2E2"/>
-          </a:solidFill>
-          <a:ln>
-            <a:solidFill>
-              <a:srgbClr val="FEE2E2"/>
-            </a:solidFill>
-          </a:ln>
-        </p:spPr>
-        <p:txBody>
-          <a:bodyPr wrap="square" lIns="0" tIns="0" rIns="0" bIns="0" rtlCol="0" anchor="ctr"/>
-          <a:lstStyle/>
-          <a:p>
-            <a:pPr algn="ctr" indent="0" marL="0">
-              <a:buNone/>
-            </a:pPr>
-            <a:r>
-              <a:rPr lang="en-US" sz="975" b="1" dirty="0">
-                <a:solidFill>
-                  <a:srgbClr val="B91C1C"/>
-                </a:solidFill>
-                <a:latin typeface="Segoe UI" pitchFamily="34" charset="0"/>
-                <a:ea typeface="Segoe UI" pitchFamily="34" charset="-122"/>
-                <a:cs typeface="Segoe UI" pitchFamily="34" charset="-120"/>
-              </a:rPr>
-              <a:t>1</a:t>
-            </a:r>
-            <a:endParaRPr lang="en-US" sz="975" dirty="0"/>
-          </a:p>
-        </p:txBody>
-      </p:sp>
-      <p:sp>
-        <p:nvSpPr>
-          <p:cNvPr id="17" name="Text 13"/>
-          <p:cNvSpPr/>
-          <p:nvPr/>
-        </p:nvSpPr>
-        <p:spPr>
-          <a:xfrm>
-            <a:off x="6859524" y="3622881"/>
-            <a:ext cx="4448556" cy="196882"/>
-          </a:xfrm>
-          <a:prstGeom prst="rect">
-            <a:avLst/>
-          </a:prstGeom>
-          <a:noFill/>
-          <a:ln/>
-        </p:spPr>
-        <p:txBody>
-          <a:bodyPr wrap="square" lIns="0" tIns="0" rIns="0" bIns="0" rtlCol="0" anchor="t"/>
-          <a:lstStyle/>
-          <a:p>
-            <a:pPr algn="l" indent="0" marL="0">
-              <a:lnSpc>
-                <a:spcPct val="115000"/>
-              </a:lnSpc>
-              <a:buNone/>
-            </a:pPr>
-            <a:r>
-              <a:rPr lang="en-US" sz="1125" dirty="0">
-                <a:solidFill>
-                  <a:srgbClr val="334155"/>
-                </a:solidFill>
-                <a:latin typeface="Segoe UI" pitchFamily="34" charset="0"/>
-                <a:ea typeface="Segoe UI" pitchFamily="34" charset="-122"/>
-                <a:cs typeface="Segoe UI" pitchFamily="34" charset="-120"/>
-              </a:rPr>
-              <a:t>Redeploy the previous data-source build and restart</a:t>
-            </a:r>
-            <a:endParaRPr lang="en-US" sz="1125" dirty="0"/>
-          </a:p>
-        </p:txBody>
-      </p:sp>
-      <p:sp>
-        <p:nvSpPr>
-          <p:cNvPr id="18" name="Text 14"/>
-          <p:cNvSpPr/>
-          <p:nvPr/>
-        </p:nvSpPr>
-        <p:spPr>
-          <a:xfrm>
-            <a:off x="6521196" y="3929491"/>
-            <a:ext cx="228600" cy="228600"/>
-          </a:xfrm>
-          <a:prstGeom prst="ellipse">
-            <a:avLst/>
-          </a:prstGeom>
-          <a:solidFill>
-            <a:srgbClr val="FEE2E2"/>
-          </a:solidFill>
-          <a:ln>
-            <a:solidFill>
-              <a:srgbClr val="FEE2E2"/>
-            </a:solidFill>
-          </a:ln>
-        </p:spPr>
-        <p:txBody>
-          <a:bodyPr wrap="square" lIns="0" tIns="0" rIns="0" bIns="0" rtlCol="0" anchor="ctr"/>
-          <a:lstStyle/>
-          <a:p>
-            <a:pPr algn="ctr" indent="0" marL="0">
-              <a:buNone/>
-            </a:pPr>
-            <a:r>
-              <a:rPr lang="en-US" sz="975" b="1" dirty="0">
-                <a:solidFill>
-                  <a:srgbClr val="B91C1C"/>
-                </a:solidFill>
-                <a:latin typeface="Segoe UI" pitchFamily="34" charset="0"/>
-                <a:ea typeface="Segoe UI" pitchFamily="34" charset="-122"/>
-                <a:cs typeface="Segoe UI" pitchFamily="34" charset="-120"/>
-              </a:rPr>
-              <a:t>2</a:t>
-            </a:r>
-            <a:endParaRPr lang="en-US" sz="975" dirty="0"/>
-          </a:p>
-        </p:txBody>
-      </p:sp>
-      <p:sp>
-        <p:nvSpPr>
-          <p:cNvPr id="19" name="Text 15"/>
-          <p:cNvSpPr/>
-          <p:nvPr/>
-        </p:nvSpPr>
-        <p:spPr>
-          <a:xfrm>
-            <a:off x="6859524" y="3956923"/>
-            <a:ext cx="4448556" cy="196882"/>
-          </a:xfrm>
-          <a:prstGeom prst="rect">
-            <a:avLst/>
-          </a:prstGeom>
-          <a:noFill/>
-          <a:ln/>
-        </p:spPr>
-        <p:txBody>
-          <a:bodyPr wrap="square" lIns="0" tIns="0" rIns="0" bIns="0" rtlCol="0" anchor="t"/>
-          <a:lstStyle/>
-          <a:p>
-            <a:pPr algn="l" indent="0" marL="0">
-              <a:lnSpc>
-                <a:spcPct val="115000"/>
-              </a:lnSpc>
-              <a:buNone/>
-            </a:pPr>
-            <a:r>
-              <a:rPr lang="en-US" sz="1125" dirty="0">
-                <a:solidFill>
-                  <a:srgbClr val="334155"/>
-                </a:solidFill>
-                <a:latin typeface="Segoe UI" pitchFamily="34" charset="0"/>
-                <a:ea typeface="Segoe UI" pitchFamily="34" charset="-122"/>
-                <a:cs typeface="Segoe UI" pitchFamily="34" charset="-120"/>
-              </a:rPr>
-              <a:t>On Sybase, the log says defaulting to PostgreSQL</a:t>
-            </a:r>
-            <a:endParaRPr lang="en-US" sz="1125" dirty="0"/>
-          </a:p>
-        </p:txBody>
-      </p:sp>
-      <p:sp>
-        <p:nvSpPr>
-          <p:cNvPr id="20" name="Text 16"/>
-          <p:cNvSpPr/>
-          <p:nvPr/>
-        </p:nvSpPr>
-        <p:spPr>
-          <a:xfrm>
-            <a:off x="6521196" y="4263533"/>
-            <a:ext cx="228600" cy="228600"/>
-          </a:xfrm>
-          <a:prstGeom prst="ellipse">
-            <a:avLst/>
-          </a:prstGeom>
-          <a:solidFill>
-            <a:srgbClr val="FEE2E2"/>
-          </a:solidFill>
-          <a:ln>
-            <a:solidFill>
-              <a:srgbClr val="FEE2E2"/>
-            </a:solidFill>
-          </a:ln>
-        </p:spPr>
-        <p:txBody>
-          <a:bodyPr wrap="square" lIns="0" tIns="0" rIns="0" bIns="0" rtlCol="0" anchor="ctr"/>
-          <a:lstStyle/>
-          <a:p>
-            <a:pPr algn="ctr" indent="0" marL="0">
-              <a:buNone/>
-            </a:pPr>
-            <a:r>
-              <a:rPr lang="en-US" sz="975" b="1" dirty="0">
-                <a:solidFill>
-                  <a:srgbClr val="B91C1C"/>
-                </a:solidFill>
-                <a:latin typeface="Segoe UI" pitchFamily="34" charset="0"/>
-                <a:ea typeface="Segoe UI" pitchFamily="34" charset="-122"/>
-                <a:cs typeface="Segoe UI" pitchFamily="34" charset="-120"/>
-              </a:rPr>
-              <a:t>3</a:t>
-            </a:r>
-            <a:endParaRPr lang="en-US" sz="975" dirty="0"/>
-          </a:p>
-        </p:txBody>
-      </p:sp>
-      <p:sp>
-        <p:nvSpPr>
-          <p:cNvPr id="21" name="Text 17"/>
-          <p:cNvSpPr/>
-          <p:nvPr/>
-        </p:nvSpPr>
-        <p:spPr>
-          <a:xfrm>
-            <a:off x="6859524" y="4290965"/>
-            <a:ext cx="4448556" cy="196882"/>
-          </a:xfrm>
-          <a:prstGeom prst="rect">
-            <a:avLst/>
-          </a:prstGeom>
-          <a:noFill/>
-          <a:ln/>
-        </p:spPr>
-        <p:txBody>
-          <a:bodyPr wrap="square" lIns="0" tIns="0" rIns="0" bIns="0" rtlCol="0" anchor="t"/>
-          <a:lstStyle/>
-          <a:p>
-            <a:pPr algn="l" indent="0" marL="0">
-              <a:lnSpc>
-                <a:spcPct val="115000"/>
-              </a:lnSpc>
-              <a:buNone/>
-            </a:pPr>
-            <a:r>
-              <a:rPr lang="en-US" sz="1125" dirty="0">
-                <a:solidFill>
-                  <a:srgbClr val="334155"/>
-                </a:solidFill>
-                <a:latin typeface="Segoe UI" pitchFamily="34" charset="0"/>
-                <a:ea typeface="Segoe UI" pitchFamily="34" charset="-122"/>
-                <a:cs typeface="Segoe UI" pitchFamily="34" charset="-120"/>
-              </a:rPr>
-              <a:t>Drop one cached type check for that hospital and lab</a:t>
-            </a:r>
-            <a:endParaRPr lang="en-US" sz="1125" dirty="0"/>
-          </a:p>
-        </p:txBody>
-      </p:sp>
-    </p:spTree>
-  </p:cSld>
-  <p:clrMapOvr>
-    <a:masterClrMapping/>
-  </p:clrMapOvr>
-</p:sld>
-</file>
-
-<file path=ppt/slides/slide7.xml><?xml version="1.0" encoding="utf-8"?>
-<p:sld xmlns:a="http://schemas.openxmlformats.org/drawingml/2006/main" xmlns:r="http://schemas.openxmlformats.org/officeDocument/2006/relationships" xmlns:p="http://schemas.openxmlformats.org/presentationml/2006/main">
-  <p:cSld name="Slide 7">
     <p:bg>
       <p:bgPr>
         <a:solidFill>

</xml_diff>

<commit_message>
vault backup: 2026-09-25 15:30:12
</commit_message>
<xml_diff>
--- a/SDLC/Projects/TMP-failure-in-removing-chinese-character-in-lis-patient-pmi-sync-svc/assets/failure-in-removing-chinese-character-in-lis-patient-pmi-sync-svc.pptx
+++ b/SDLC/Projects/TMP-failure-in-removing-chinese-character-in-lis-patient-pmi-sync-svc/assets/failure-in-removing-chinese-character-in-lis-patient-pmi-sync-svc.pptx
@@ -3802,141 +3802,6 @@
           </a:p>
         </p:txBody>
       </p:sp>
-      <p:sp>
-        <p:nvSpPr>
-          <p:cNvPr id="12" name="Shape 8"/>
-          <p:cNvSpPr/>
-          <p:nvPr/>
-        </p:nvSpPr>
-        <p:spPr>
-          <a:xfrm>
-            <a:off x="8077200" y="2860834"/>
-            <a:ext cx="3505200" cy="2050732"/>
-          </a:xfrm>
-          <a:prstGeom prst="roundRect">
-            <a:avLst>
-              <a:gd name="adj" fmla="val 5351"/>
-            </a:avLst>
-          </a:prstGeom>
-          <a:solidFill>
-            <a:srgbClr val="FFFFFF"/>
-          </a:solidFill>
-          <a:ln w="9525">
-            <a:solidFill>
-              <a:srgbClr val="E2E8F0"/>
-            </a:solidFill>
-            <a:prstDash val="solid"/>
-          </a:ln>
-        </p:spPr>
-      </p:sp>
-      <p:pic>
-        <p:nvPicPr>
-          <p:cNvPr id="13" name="Image 2" descr="D:\Github\HA-Notes\LIS\skills\design-review-pptx\assets\icons\png\accent\hospital.png">    </p:cNvPr>
-          <p:cNvPicPr>
-            <a:picLocks noChangeAspect="1"/>
-          </p:cNvPicPr>
-          <p:nvPr/>
-        </p:nvPicPr>
-        <p:blipFill>
-          <a:blip r:embed="rId3"/>
-          <a:stretch>
-            <a:fillRect/>
-          </a:stretch>
-        </p:blipFill>
-        <p:spPr>
-          <a:xfrm>
-            <a:off x="8351520" y="3180874"/>
-            <a:ext cx="265176" cy="265176"/>
-          </a:xfrm>
-          <a:prstGeom prst="rect">
-            <a:avLst/>
-          </a:prstGeom>
-        </p:spPr>
-      </p:pic>
-      <p:sp>
-        <p:nvSpPr>
-          <p:cNvPr id="14" name="Text 9"/>
-          <p:cNvSpPr/>
-          <p:nvPr/>
-        </p:nvSpPr>
-        <p:spPr>
-          <a:xfrm>
-            <a:off x="8351520" y="3638074"/>
-            <a:ext cx="2956560" cy="219075"/>
-          </a:xfrm>
-          <a:prstGeom prst="rect">
-            <a:avLst/>
-          </a:prstGeom>
-          <a:noFill/>
-          <a:ln/>
-        </p:spPr>
-        <p:txBody>
-          <a:bodyPr wrap="square" lIns="0" tIns="0" rIns="0" bIns="0" rtlCol="0" anchor="t"/>
-          <a:lstStyle/>
-          <a:p>
-            <a:pPr algn="l" indent="0" marL="0">
-              <a:lnSpc>
-                <a:spcPct val="110000"/>
-              </a:lnSpc>
-              <a:buNone/>
-            </a:pPr>
-            <a:r>
-              <a:rPr lang="en-US" sz="1500" dirty="0">
-                <a:solidFill>
-                  <a:srgbClr val="0F172A"/>
-                </a:solidFill>
-                <a:latin typeface="Segoe UI Semibold" pitchFamily="34" charset="0"/>
-                <a:ea typeface="Segoe UI Semibold" pitchFamily="34" charset="-122"/>
-                <a:cs typeface="Segoe UI Semibold" pitchFamily="34" charset="-120"/>
-              </a:rPr>
-              <a:t>Hospital work stays open</a:t>
-            </a:r>
-            <a:endParaRPr lang="en-US" sz="1500" dirty="0"/>
-          </a:p>
-        </p:txBody>
-      </p:sp>
-      <p:sp>
-        <p:nvSpPr>
-          <p:cNvPr id="15" name="Text 10"/>
-          <p:cNvSpPr/>
-          <p:nvPr/>
-        </p:nvSpPr>
-        <p:spPr>
-          <a:xfrm>
-            <a:off x="8351520" y="3948589"/>
-            <a:ext cx="2956560" cy="798385"/>
-          </a:xfrm>
-          <a:prstGeom prst="rect">
-            <a:avLst/>
-          </a:prstGeom>
-          <a:noFill/>
-          <a:ln/>
-        </p:spPr>
-        <p:txBody>
-          <a:bodyPr wrap="square" lIns="0" tIns="0" rIns="0" bIns="0" rtlCol="0" anchor="t"/>
-          <a:lstStyle/>
-          <a:p>
-            <a:pPr algn="l" indent="0" marL="0">
-              <a:lnSpc>
-                <a:spcPct val="120000"/>
-              </a:lnSpc>
-              <a:buNone/>
-            </a:pPr>
-            <a:r>
-              <a:rPr lang="en-US" sz="1350" dirty="0">
-                <a:solidFill>
-                  <a:srgbClr val="475569"/>
-                </a:solidFill>
-                <a:latin typeface="Segoe UI" pitchFamily="34" charset="0"/>
-                <a:ea typeface="Segoe UI" pitchFamily="34" charset="-122"/>
-                <a:cs typeface="Segoe UI" pitchFamily="34" charset="-120"/>
-              </a:rPr>
-              <a:t>Do not switch the hospital transaction over to Oracle.</a:t>
-            </a:r>
-            <a:endParaRPr lang="en-US" sz="1350" dirty="0"/>
-          </a:p>
-        </p:txBody>
-      </p:sp>
     </p:spTree>
   </p:cSld>
   <p:clrMapOvr>

</xml_diff>

<commit_message>
vault backup: 2026-09-25 15:31:45
</commit_message>
<xml_diff>
--- a/SDLC/Projects/TMP-failure-in-removing-chinese-character-in-lis-patient-pmi-sync-svc/assets/failure-in-removing-chinese-character-in-lis-patient-pmi-sync-svc.pptx
+++ b/SDLC/Projects/TMP-failure-in-removing-chinese-character-in-lis-patient-pmi-sync-svc/assets/failure-in-removing-chinese-character-in-lis-patient-pmi-sync-svc.pptx
@@ -3540,12 +3540,12 @@
         </p:nvSpPr>
         <p:spPr>
           <a:xfrm>
-            <a:off x="609600" y="2860834"/>
-            <a:ext cx="3505200" cy="2050732"/>
+            <a:off x="609600" y="2967990"/>
+            <a:ext cx="5335524" cy="1836420"/>
           </a:xfrm>
           <a:prstGeom prst="roundRect">
             <a:avLst>
-              <a:gd name="adj" fmla="val 5351"/>
+              <a:gd name="adj" fmla="val 5975"/>
             </a:avLst>
           </a:prstGeom>
           <a:solidFill>
@@ -3575,7 +3575,7 @@
         </p:blipFill>
         <p:spPr>
           <a:xfrm>
-            <a:off x="883920" y="3180874"/>
+            <a:off x="883920" y="3288030"/>
             <a:ext cx="265176" cy="265176"/>
           </a:xfrm>
           <a:prstGeom prst="rect">
@@ -3591,8 +3591,8 @@
         </p:nvSpPr>
         <p:spPr>
           <a:xfrm>
-            <a:off x="883920" y="3638074"/>
-            <a:ext cx="2956560" cy="219075"/>
+            <a:off x="883920" y="3745230"/>
+            <a:ext cx="4786884" cy="219075"/>
           </a:xfrm>
           <a:prstGeom prst="rect">
             <a:avLst/>
@@ -3633,8 +3633,8 @@
         </p:nvSpPr>
         <p:spPr>
           <a:xfrm>
-            <a:off x="883920" y="3948589"/>
-            <a:ext cx="2956560" cy="798385"/>
+            <a:off x="883920" y="4055745"/>
+            <a:ext cx="4786884" cy="584073"/>
           </a:xfrm>
           <a:prstGeom prst="rect">
             <a:avLst/>
@@ -3675,12 +3675,12 @@
         </p:nvSpPr>
         <p:spPr>
           <a:xfrm>
-            <a:off x="4343400" y="2860834"/>
-            <a:ext cx="3505200" cy="2050732"/>
+            <a:off x="6246876" y="2967990"/>
+            <a:ext cx="5335524" cy="1836420"/>
           </a:xfrm>
           <a:prstGeom prst="roundRect">
             <a:avLst>
-              <a:gd name="adj" fmla="val 5351"/>
+              <a:gd name="adj" fmla="val 5975"/>
             </a:avLst>
           </a:prstGeom>
           <a:solidFill>
@@ -3710,7 +3710,7 @@
         </p:blipFill>
         <p:spPr>
           <a:xfrm>
-            <a:off x="4617720" y="3180874"/>
+            <a:off x="6521196" y="3288030"/>
             <a:ext cx="265176" cy="265176"/>
           </a:xfrm>
           <a:prstGeom prst="rect">
@@ -3726,8 +3726,8 @@
         </p:nvSpPr>
         <p:spPr>
           <a:xfrm>
-            <a:off x="4617720" y="3638074"/>
-            <a:ext cx="2956560" cy="219075"/>
+            <a:off x="6521196" y="3745230"/>
+            <a:ext cx="4786884" cy="219075"/>
           </a:xfrm>
           <a:prstGeom prst="rect">
             <a:avLst/>
@@ -3768,8 +3768,8 @@
         </p:nvSpPr>
         <p:spPr>
           <a:xfrm>
-            <a:off x="4617720" y="3948589"/>
-            <a:ext cx="2956560" cy="798385"/>
+            <a:off x="6521196" y="4055745"/>
+            <a:ext cx="4786884" cy="584073"/>
           </a:xfrm>
           <a:prstGeom prst="rect">
             <a:avLst/>

</xml_diff>

<commit_message>
vault backup: 2026-09-25 15:36:41
</commit_message>
<xml_diff>
--- a/SDLC/Projects/TMP-failure-in-removing-chinese-character-in-lis-patient-pmi-sync-svc/assets/failure-in-removing-chinese-character-in-lis-patient-pmi-sync-svc.pptx
+++ b/SDLC/Projects/TMP-failure-in-removing-chinese-character-in-lis-patient-pmi-sync-svc/assets/failure-in-removing-chinese-character-in-lis-patient-pmi-sync-svc.pptx
@@ -3920,12 +3920,12 @@
         </p:nvSpPr>
         <p:spPr>
           <a:xfrm>
-            <a:off x="609600" y="2873073"/>
-            <a:ext cx="5335524" cy="2026253"/>
+            <a:off x="609600" y="3063240"/>
+            <a:ext cx="5335524" cy="1645920"/>
           </a:xfrm>
           <a:prstGeom prst="roundRect">
             <a:avLst>
-              <a:gd name="adj" fmla="val 5415"/>
+              <a:gd name="adj" fmla="val 6667"/>
             </a:avLst>
           </a:prstGeom>
           <a:solidFill>
@@ -3955,7 +3955,7 @@
         </p:blipFill>
         <p:spPr>
           <a:xfrm>
-            <a:off x="883920" y="3179397"/>
+            <a:off x="883920" y="3369564"/>
             <a:ext cx="265176" cy="265176"/>
           </a:xfrm>
           <a:prstGeom prst="rect">
@@ -3971,7 +3971,7 @@
         </p:nvSpPr>
         <p:spPr>
           <a:xfrm>
-            <a:off x="1249680" y="3165681"/>
+            <a:off x="1249680" y="3355848"/>
             <a:ext cx="4421124" cy="292608"/>
           </a:xfrm>
           <a:prstGeom prst="rect">
@@ -4013,7 +4013,7 @@
         </p:nvSpPr>
         <p:spPr>
           <a:xfrm>
-            <a:off x="883920" y="3595449"/>
+            <a:off x="883920" y="3785616"/>
             <a:ext cx="228600" cy="228600"/>
           </a:xfrm>
           <a:prstGeom prst="ellipse">
@@ -4058,7 +4058,7 @@
         </p:nvSpPr>
         <p:spPr>
           <a:xfrm>
-            <a:off x="1222248" y="3622881"/>
+            <a:off x="1222248" y="3813048"/>
             <a:ext cx="4448556" cy="196882"/>
           </a:xfrm>
           <a:prstGeom prst="rect">
@@ -4086,7 +4086,7 @@
                 <a:ea typeface="Segoe UI" pitchFamily="34" charset="-122"/>
                 <a:cs typeface="Segoe UI" pitchFamily="34" charset="-120"/>
               </a:rPr>
-              <a:t>Ship a new data-source build</a:t>
+              <a:t>Deploy lis-patient-pmi-sync-svc</a:t>
             </a:r>
             <a:endParaRPr lang="en-US" sz="1125" dirty="0"/>
           </a:p>
@@ -4094,192 +4094,18 @@
       </p:sp>
       <p:sp>
         <p:nvSpPr>
-          <p:cNvPr id="9" name="Text 6"/>
-          <p:cNvSpPr/>
-          <p:nvPr/>
-        </p:nvSpPr>
-        <p:spPr>
-          <a:xfrm>
-            <a:off x="883920" y="3929491"/>
-            <a:ext cx="228600" cy="228600"/>
-          </a:xfrm>
-          <a:prstGeom prst="ellipse">
-            <a:avLst/>
-          </a:prstGeom>
-          <a:solidFill>
-            <a:srgbClr val="DCFCE7"/>
-          </a:solidFill>
-          <a:ln>
-            <a:solidFill>
-              <a:srgbClr val="DCFCE7"/>
-            </a:solidFill>
-          </a:ln>
-        </p:spPr>
-        <p:txBody>
-          <a:bodyPr wrap="square" lIns="0" tIns="0" rIns="0" bIns="0" rtlCol="0" anchor="ctr"/>
-          <a:lstStyle/>
-          <a:p>
-            <a:pPr algn="ctr" indent="0" marL="0">
-              <a:buNone/>
-            </a:pPr>
-            <a:r>
-              <a:rPr lang="en-US" sz="975" b="1" dirty="0">
-                <a:solidFill>
-                  <a:srgbClr val="15803D"/>
-                </a:solidFill>
-                <a:latin typeface="Segoe UI" pitchFamily="34" charset="0"/>
-                <a:ea typeface="Segoe UI" pitchFamily="34" charset="-122"/>
-                <a:cs typeface="Segoe UI" pitchFamily="34" charset="-120"/>
-              </a:rPr>
-              <a:t>2</a:t>
-            </a:r>
-            <a:endParaRPr lang="en-US" sz="975" dirty="0"/>
-          </a:p>
-        </p:txBody>
-      </p:sp>
-      <p:sp>
-        <p:nvSpPr>
-          <p:cNvPr id="10" name="Text 7"/>
-          <p:cNvSpPr/>
-          <p:nvPr/>
-        </p:nvSpPr>
-        <p:spPr>
-          <a:xfrm>
-            <a:off x="1222248" y="3956923"/>
-            <a:ext cx="4448556" cy="196882"/>
-          </a:xfrm>
-          <a:prstGeom prst="rect">
-            <a:avLst/>
-          </a:prstGeom>
-          <a:noFill/>
-          <a:ln/>
-        </p:spPr>
-        <p:txBody>
-          <a:bodyPr wrap="square" lIns="0" tIns="0" rIns="0" bIns="0" rtlCol="0" anchor="t"/>
-          <a:lstStyle/>
-          <a:p>
-            <a:pPr algn="l" indent="0" marL="0">
-              <a:lnSpc>
-                <a:spcPct val="115000"/>
-              </a:lnSpc>
-              <a:buNone/>
-            </a:pPr>
-            <a:r>
-              <a:rPr lang="en-US" sz="1125" dirty="0">
-                <a:solidFill>
-                  <a:srgbClr val="334155"/>
-                </a:solidFill>
-                <a:latin typeface="Segoe UI" pitchFamily="34" charset="0"/>
-                <a:ea typeface="Segoe UI" pitchFamily="34" charset="-122"/>
-                <a:cs typeface="Segoe UI" pitchFamily="34" charset="-120"/>
-              </a:rPr>
-              <a:t>Leave JDBC settings unchanged in DEVQA, SIT, and PROD</a:t>
-            </a:r>
-            <a:endParaRPr lang="en-US" sz="1125" dirty="0"/>
-          </a:p>
-        </p:txBody>
-      </p:sp>
-      <p:sp>
-        <p:nvSpPr>
-          <p:cNvPr id="11" name="Text 8"/>
-          <p:cNvSpPr/>
-          <p:nvPr/>
-        </p:nvSpPr>
-        <p:spPr>
-          <a:xfrm>
-            <a:off x="883920" y="4263533"/>
-            <a:ext cx="228600" cy="228600"/>
-          </a:xfrm>
-          <a:prstGeom prst="ellipse">
-            <a:avLst/>
-          </a:prstGeom>
-          <a:solidFill>
-            <a:srgbClr val="DCFCE7"/>
-          </a:solidFill>
-          <a:ln>
-            <a:solidFill>
-              <a:srgbClr val="DCFCE7"/>
-            </a:solidFill>
-          </a:ln>
-        </p:spPr>
-        <p:txBody>
-          <a:bodyPr wrap="square" lIns="0" tIns="0" rIns="0" bIns="0" rtlCol="0" anchor="ctr"/>
-          <a:lstStyle/>
-          <a:p>
-            <a:pPr algn="ctr" indent="0" marL="0">
-              <a:buNone/>
-            </a:pPr>
-            <a:r>
-              <a:rPr lang="en-US" sz="975" b="1" dirty="0">
-                <a:solidFill>
-                  <a:srgbClr val="15803D"/>
-                </a:solidFill>
-                <a:latin typeface="Segoe UI" pitchFamily="34" charset="0"/>
-                <a:ea typeface="Segoe UI" pitchFamily="34" charset="-122"/>
-                <a:cs typeface="Segoe UI" pitchFamily="34" charset="-120"/>
-              </a:rPr>
-              <a:t>3</a:t>
-            </a:r>
-            <a:endParaRPr lang="en-US" sz="975" dirty="0"/>
-          </a:p>
-        </p:txBody>
-      </p:sp>
-      <p:sp>
-        <p:nvSpPr>
-          <p:cNvPr id="12" name="Text 9"/>
-          <p:cNvSpPr/>
-          <p:nvPr/>
-        </p:nvSpPr>
-        <p:spPr>
-          <a:xfrm>
-            <a:off x="1222248" y="4290965"/>
-            <a:ext cx="4448556" cy="196882"/>
-          </a:xfrm>
-          <a:prstGeom prst="rect">
-            <a:avLst/>
-          </a:prstGeom>
-          <a:noFill/>
-          <a:ln/>
-        </p:spPr>
-        <p:txBody>
-          <a:bodyPr wrap="square" lIns="0" tIns="0" rIns="0" bIns="0" rtlCol="0" anchor="t"/>
-          <a:lstStyle/>
-          <a:p>
-            <a:pPr algn="l" indent="0" marL="0">
-              <a:lnSpc>
-                <a:spcPct val="115000"/>
-              </a:lnSpc>
-              <a:buNone/>
-            </a:pPr>
-            <a:r>
-              <a:rPr lang="en-US" sz="1125" dirty="0">
-                <a:solidFill>
-                  <a:srgbClr val="334155"/>
-                </a:solidFill>
-                <a:latin typeface="Segoe UI" pitchFamily="34" charset="0"/>
-                <a:ea typeface="Segoe UI" pitchFamily="34" charset="-122"/>
-                <a:cs typeface="Segoe UI" pitchFamily="34" charset="-120"/>
-              </a:rPr>
-              <a:t>Rebuild lis-patient-pmi-sync-svc. Its source stays the same</a:t>
-            </a:r>
-            <a:endParaRPr lang="en-US" sz="1125" dirty="0"/>
-          </a:p>
-        </p:txBody>
-      </p:sp>
-      <p:sp>
-        <p:nvSpPr>
-          <p:cNvPr id="13" name="Shape 10"/>
-          <p:cNvSpPr/>
-          <p:nvPr/>
-        </p:nvSpPr>
-        <p:spPr>
-          <a:xfrm>
-            <a:off x="6246876" y="2873073"/>
-            <a:ext cx="5335524" cy="2026253"/>
+          <p:cNvPr id="9" name="Shape 6"/>
+          <p:cNvSpPr/>
+          <p:nvPr/>
+        </p:nvSpPr>
+        <p:spPr>
+          <a:xfrm>
+            <a:off x="6246876" y="3063240"/>
+            <a:ext cx="5335524" cy="1645920"/>
           </a:xfrm>
           <a:prstGeom prst="roundRect">
             <a:avLst>
-              <a:gd name="adj" fmla="val 5415"/>
+              <a:gd name="adj" fmla="val 6667"/>
             </a:avLst>
           </a:prstGeom>
           <a:solidFill>
@@ -4295,7 +4121,7 @@
       </p:sp>
       <p:pic>
         <p:nvPicPr>
-          <p:cNvPr id="14" name="Image 1" descr="D:\Github\HA-Notes\LIS\skills\design-review-pptx\assets\icons\png\danger\rotate-left.png">    </p:cNvPr>
+          <p:cNvPr id="10" name="Image 1" descr="D:\Github\HA-Notes\LIS\skills\design-review-pptx\assets\icons\png\danger\rotate-left.png">    </p:cNvPr>
           <p:cNvPicPr>
             <a:picLocks noChangeAspect="1"/>
           </p:cNvPicPr>
@@ -4309,7 +4135,7 @@
         </p:blipFill>
         <p:spPr>
           <a:xfrm>
-            <a:off x="6521196" y="3179397"/>
+            <a:off x="6521196" y="3369564"/>
             <a:ext cx="265176" cy="265176"/>
           </a:xfrm>
           <a:prstGeom prst="rect">
@@ -4319,13 +4145,13 @@
       </p:pic>
       <p:sp>
         <p:nvSpPr>
-          <p:cNvPr id="15" name="Text 11"/>
-          <p:cNvSpPr/>
-          <p:nvPr/>
-        </p:nvSpPr>
-        <p:spPr>
-          <a:xfrm>
-            <a:off x="6886956" y="3165681"/>
+          <p:cNvPr id="11" name="Text 7"/>
+          <p:cNvSpPr/>
+          <p:nvPr/>
+        </p:nvSpPr>
+        <p:spPr>
+          <a:xfrm>
+            <a:off x="6886956" y="3355848"/>
             <a:ext cx="4421124" cy="292608"/>
           </a:xfrm>
           <a:prstGeom prst="rect">
@@ -4361,13 +4187,13 @@
       </p:sp>
       <p:sp>
         <p:nvSpPr>
-          <p:cNvPr id="16" name="Text 12"/>
-          <p:cNvSpPr/>
-          <p:nvPr/>
-        </p:nvSpPr>
-        <p:spPr>
-          <a:xfrm>
-            <a:off x="6521196" y="3595449"/>
+          <p:cNvPr id="12" name="Text 8"/>
+          <p:cNvSpPr/>
+          <p:nvPr/>
+        </p:nvSpPr>
+        <p:spPr>
+          <a:xfrm>
+            <a:off x="6521196" y="3785616"/>
             <a:ext cx="228600" cy="228600"/>
           </a:xfrm>
           <a:prstGeom prst="ellipse">
@@ -4406,13 +4232,13 @@
       </p:sp>
       <p:sp>
         <p:nvSpPr>
-          <p:cNvPr id="17" name="Text 13"/>
-          <p:cNvSpPr/>
-          <p:nvPr/>
-        </p:nvSpPr>
-        <p:spPr>
-          <a:xfrm>
-            <a:off x="6859524" y="3622881"/>
+          <p:cNvPr id="13" name="Text 9"/>
+          <p:cNvSpPr/>
+          <p:nvPr/>
+        </p:nvSpPr>
+        <p:spPr>
+          <a:xfrm>
+            <a:off x="6859524" y="3813048"/>
             <a:ext cx="4448556" cy="196882"/>
           </a:xfrm>
           <a:prstGeom prst="rect">
@@ -4440,181 +4266,7 @@
                 <a:ea typeface="Segoe UI" pitchFamily="34" charset="-122"/>
                 <a:cs typeface="Segoe UI" pitchFamily="34" charset="-120"/>
               </a:rPr>
-              <a:t>Redeploy the previous data-source build and restart</a:t>
-            </a:r>
-            <a:endParaRPr lang="en-US" sz="1125" dirty="0"/>
-          </a:p>
-        </p:txBody>
-      </p:sp>
-      <p:sp>
-        <p:nvSpPr>
-          <p:cNvPr id="18" name="Text 14"/>
-          <p:cNvSpPr/>
-          <p:nvPr/>
-        </p:nvSpPr>
-        <p:spPr>
-          <a:xfrm>
-            <a:off x="6521196" y="3929491"/>
-            <a:ext cx="228600" cy="228600"/>
-          </a:xfrm>
-          <a:prstGeom prst="ellipse">
-            <a:avLst/>
-          </a:prstGeom>
-          <a:solidFill>
-            <a:srgbClr val="FEE2E2"/>
-          </a:solidFill>
-          <a:ln>
-            <a:solidFill>
-              <a:srgbClr val="FEE2E2"/>
-            </a:solidFill>
-          </a:ln>
-        </p:spPr>
-        <p:txBody>
-          <a:bodyPr wrap="square" lIns="0" tIns="0" rIns="0" bIns="0" rtlCol="0" anchor="ctr"/>
-          <a:lstStyle/>
-          <a:p>
-            <a:pPr algn="ctr" indent="0" marL="0">
-              <a:buNone/>
-            </a:pPr>
-            <a:r>
-              <a:rPr lang="en-US" sz="975" b="1" dirty="0">
-                <a:solidFill>
-                  <a:srgbClr val="B91C1C"/>
-                </a:solidFill>
-                <a:latin typeface="Segoe UI" pitchFamily="34" charset="0"/>
-                <a:ea typeface="Segoe UI" pitchFamily="34" charset="-122"/>
-                <a:cs typeface="Segoe UI" pitchFamily="34" charset="-120"/>
-              </a:rPr>
-              <a:t>2</a:t>
-            </a:r>
-            <a:endParaRPr lang="en-US" sz="975" dirty="0"/>
-          </a:p>
-        </p:txBody>
-      </p:sp>
-      <p:sp>
-        <p:nvSpPr>
-          <p:cNvPr id="19" name="Text 15"/>
-          <p:cNvSpPr/>
-          <p:nvPr/>
-        </p:nvSpPr>
-        <p:spPr>
-          <a:xfrm>
-            <a:off x="6859524" y="3956923"/>
-            <a:ext cx="4448556" cy="196882"/>
-          </a:xfrm>
-          <a:prstGeom prst="rect">
-            <a:avLst/>
-          </a:prstGeom>
-          <a:noFill/>
-          <a:ln/>
-        </p:spPr>
-        <p:txBody>
-          <a:bodyPr wrap="square" lIns="0" tIns="0" rIns="0" bIns="0" rtlCol="0" anchor="t"/>
-          <a:lstStyle/>
-          <a:p>
-            <a:pPr algn="l" indent="0" marL="0">
-              <a:lnSpc>
-                <a:spcPct val="115000"/>
-              </a:lnSpc>
-              <a:buNone/>
-            </a:pPr>
-            <a:r>
-              <a:rPr lang="en-US" sz="1125" dirty="0">
-                <a:solidFill>
-                  <a:srgbClr val="334155"/>
-                </a:solidFill>
-                <a:latin typeface="Segoe UI" pitchFamily="34" charset="0"/>
-                <a:ea typeface="Segoe UI" pitchFamily="34" charset="-122"/>
-                <a:cs typeface="Segoe UI" pitchFamily="34" charset="-120"/>
-              </a:rPr>
-              <a:t>On Sybase, the log says defaulting to PostgreSQL</a:t>
-            </a:r>
-            <a:endParaRPr lang="en-US" sz="1125" dirty="0"/>
-          </a:p>
-        </p:txBody>
-      </p:sp>
-      <p:sp>
-        <p:nvSpPr>
-          <p:cNvPr id="20" name="Text 16"/>
-          <p:cNvSpPr/>
-          <p:nvPr/>
-        </p:nvSpPr>
-        <p:spPr>
-          <a:xfrm>
-            <a:off x="6521196" y="4263533"/>
-            <a:ext cx="228600" cy="228600"/>
-          </a:xfrm>
-          <a:prstGeom prst="ellipse">
-            <a:avLst/>
-          </a:prstGeom>
-          <a:solidFill>
-            <a:srgbClr val="FEE2E2"/>
-          </a:solidFill>
-          <a:ln>
-            <a:solidFill>
-              <a:srgbClr val="FEE2E2"/>
-            </a:solidFill>
-          </a:ln>
-        </p:spPr>
-        <p:txBody>
-          <a:bodyPr wrap="square" lIns="0" tIns="0" rIns="0" bIns="0" rtlCol="0" anchor="ctr"/>
-          <a:lstStyle/>
-          <a:p>
-            <a:pPr algn="ctr" indent="0" marL="0">
-              <a:buNone/>
-            </a:pPr>
-            <a:r>
-              <a:rPr lang="en-US" sz="975" b="1" dirty="0">
-                <a:solidFill>
-                  <a:srgbClr val="B91C1C"/>
-                </a:solidFill>
-                <a:latin typeface="Segoe UI" pitchFamily="34" charset="0"/>
-                <a:ea typeface="Segoe UI" pitchFamily="34" charset="-122"/>
-                <a:cs typeface="Segoe UI" pitchFamily="34" charset="-120"/>
-              </a:rPr>
-              <a:t>3</a:t>
-            </a:r>
-            <a:endParaRPr lang="en-US" sz="975" dirty="0"/>
-          </a:p>
-        </p:txBody>
-      </p:sp>
-      <p:sp>
-        <p:nvSpPr>
-          <p:cNvPr id="21" name="Text 17"/>
-          <p:cNvSpPr/>
-          <p:nvPr/>
-        </p:nvSpPr>
-        <p:spPr>
-          <a:xfrm>
-            <a:off x="6859524" y="4290965"/>
-            <a:ext cx="4448556" cy="196882"/>
-          </a:xfrm>
-          <a:prstGeom prst="rect">
-            <a:avLst/>
-          </a:prstGeom>
-          <a:noFill/>
-          <a:ln/>
-        </p:spPr>
-        <p:txBody>
-          <a:bodyPr wrap="square" lIns="0" tIns="0" rIns="0" bIns="0" rtlCol="0" anchor="t"/>
-          <a:lstStyle/>
-          <a:p>
-            <a:pPr algn="l" indent="0" marL="0">
-              <a:lnSpc>
-                <a:spcPct val="115000"/>
-              </a:lnSpc>
-              <a:buNone/>
-            </a:pPr>
-            <a:r>
-              <a:rPr lang="en-US" sz="1125" dirty="0">
-                <a:solidFill>
-                  <a:srgbClr val="334155"/>
-                </a:solidFill>
-                <a:latin typeface="Segoe UI" pitchFamily="34" charset="0"/>
-                <a:ea typeface="Segoe UI" pitchFamily="34" charset="-122"/>
-                <a:cs typeface="Segoe UI" pitchFamily="34" charset="-120"/>
-              </a:rPr>
-              <a:t>Drop one cached type check for that hospital and lab</a:t>
+              <a:t>Undeploy lis-patient-pmi-sync-svc</a:t>
             </a:r>
             <a:endParaRPr lang="en-US" sz="1125" dirty="0"/>
           </a:p>

</xml_diff>